<commit_message>
Remove metadata lines from presentation cover
</commit_message>
<xml_diff>
--- a/Cybersecurity_AI_Copilot_Presentation.pptx
+++ b/Cybersecurity_AI_Copilot_Presentation.pptx
@@ -2,21 +2,21 @@
 <file path=ppt/presentation.xml><?xml version="1.0" encoding="utf-8"?>
 <p:presentation xmlns:p="http://schemas.openxmlformats.org/presentationml/2006/main">
   <p:sldMasterIdLst>
-    <p:sldMasterId xmlns:r="http://schemas.openxmlformats.org/officeDocument/2006/relationships" id="2147483648" r:id="R797cce477e454dc6"/>
+    <p:sldMasterId xmlns:r="http://schemas.openxmlformats.org/officeDocument/2006/relationships" id="2147483648" r:id="R055e6f42697d47af"/>
   </p:sldMasterIdLst>
   <p:notesMasterIdLst>
-    <p:notesMasterId xmlns:r="http://schemas.openxmlformats.org/officeDocument/2006/relationships" r:id="R671d76339d2e4dfb"/>
+    <p:notesMasterId xmlns:r="http://schemas.openxmlformats.org/officeDocument/2006/relationships" r:id="R63ace34f6d36451c"/>
   </p:notesMasterIdLst>
   <p:sldIdLst>
-    <p:sldId xmlns:r="http://schemas.openxmlformats.org/officeDocument/2006/relationships" id="256" r:id="Rafbdf306a2344e44"/>
-    <p:sldId xmlns:r="http://schemas.openxmlformats.org/officeDocument/2006/relationships" id="257" r:id="R87e931526ea24f80"/>
-    <p:sldId xmlns:r="http://schemas.openxmlformats.org/officeDocument/2006/relationships" id="258" r:id="R71c934ba876e47ca"/>
-    <p:sldId xmlns:r="http://schemas.openxmlformats.org/officeDocument/2006/relationships" id="259" r:id="Rc7a2b97826ff4464"/>
-    <p:sldId xmlns:r="http://schemas.openxmlformats.org/officeDocument/2006/relationships" id="260" r:id="R87d9ff0491b642ce"/>
-    <p:sldId xmlns:r="http://schemas.openxmlformats.org/officeDocument/2006/relationships" id="261" r:id="R3fa0b7c57316423f"/>
-    <p:sldId xmlns:r="http://schemas.openxmlformats.org/officeDocument/2006/relationships" id="262" r:id="R03d1e4b5a03e46d0"/>
-    <p:sldId xmlns:r="http://schemas.openxmlformats.org/officeDocument/2006/relationships" id="263" r:id="R4a6b69716d2b42d1"/>
-    <p:sldId xmlns:r="http://schemas.openxmlformats.org/officeDocument/2006/relationships" id="264" r:id="R6c59932415ef4b69"/>
+    <p:sldId xmlns:r="http://schemas.openxmlformats.org/officeDocument/2006/relationships" id="256" r:id="Rd6b483765baa42c0"/>
+    <p:sldId xmlns:r="http://schemas.openxmlformats.org/officeDocument/2006/relationships" id="257" r:id="R6b6aa9ff41734e1f"/>
+    <p:sldId xmlns:r="http://schemas.openxmlformats.org/officeDocument/2006/relationships" id="258" r:id="Rb5d642d5d4f94491"/>
+    <p:sldId xmlns:r="http://schemas.openxmlformats.org/officeDocument/2006/relationships" id="259" r:id="Rf1fa0b05e5824f26"/>
+    <p:sldId xmlns:r="http://schemas.openxmlformats.org/officeDocument/2006/relationships" id="260" r:id="R2ce00d252c934190"/>
+    <p:sldId xmlns:r="http://schemas.openxmlformats.org/officeDocument/2006/relationships" id="261" r:id="R1746e8d6bc46417d"/>
+    <p:sldId xmlns:r="http://schemas.openxmlformats.org/officeDocument/2006/relationships" id="262" r:id="Ra97d2a7dd82048ea"/>
+    <p:sldId xmlns:r="http://schemas.openxmlformats.org/officeDocument/2006/relationships" id="263" r:id="R526e421fc56344bb"/>
+    <p:sldId xmlns:r="http://schemas.openxmlformats.org/officeDocument/2006/relationships" id="264" r:id="R5d61cdbc2ec24a3d"/>
   </p:sldIdLst>
   <p:sldSz cx="12192000" cy="6858000"/>
   <p:notesSz cx="6858000" cy="9144000"/>
@@ -1057,7 +1057,7 @@
           <p:cNvPr id="3" name="Title">
             <a:extLst xmlns:a="http://schemas.openxmlformats.org/drawingml/2006/main">
               <a:ext uri="{FF2B5EF4-FFF2-40B4-BE49-F238E27FC236}">
-                <a16:creationId xmlns:a16="http://schemas.microsoft.com/office/drawing/2014/main" id="{C6BE6825-8116-4041-BC37-90A7E4320B71}"/>
+                <a16:creationId xmlns:a16="http://schemas.microsoft.com/office/drawing/2014/main" id="{C1F98248-E971-40E5-A978-8BB2B45E2771}"/>
               </a:ext>
             </a:extLst>
           </p:cNvPr>
@@ -1286,7 +1286,7 @@
           <p:cNvPr id="2" name="Subtitle">
             <a:extLst xmlns:a="http://schemas.openxmlformats.org/drawingml/2006/main">
               <a:ext uri="{FF2B5EF4-FFF2-40B4-BE49-F238E27FC236}">
-                <a16:creationId xmlns:a16="http://schemas.microsoft.com/office/drawing/2014/main" id="{B93BA787-4132-40BE-9CBD-09DEB5012812}"/>
+                <a16:creationId xmlns:a16="http://schemas.microsoft.com/office/drawing/2014/main" id="{40F29AE5-DFD7-476D-86A6-CD98ECAA01D7}"/>
               </a:ext>
             </a:extLst>
           </p:cNvPr>
@@ -1532,7 +1532,7 @@
           <p:cNvPr id="2" name="Section title">
             <a:extLst xmlns:a="http://schemas.openxmlformats.org/drawingml/2006/main">
               <a:ext uri="{FF2B5EF4-FFF2-40B4-BE49-F238E27FC236}">
-                <a16:creationId xmlns:a16="http://schemas.microsoft.com/office/drawing/2014/main" id="{C5B02721-A8D1-4900-90AF-28CE1EE6A085}"/>
+                <a16:creationId xmlns:a16="http://schemas.microsoft.com/office/drawing/2014/main" id="{7E7DAB09-322B-4E02-B5CE-2B87A84559D5}"/>
               </a:ext>
             </a:extLst>
           </p:cNvPr>
@@ -1778,7 +1778,7 @@
           <p:cNvPr id="3" name="Title">
             <a:extLst xmlns:a="http://schemas.openxmlformats.org/drawingml/2006/main">
               <a:ext uri="{FF2B5EF4-FFF2-40B4-BE49-F238E27FC236}">
-                <a16:creationId xmlns:a16="http://schemas.microsoft.com/office/drawing/2014/main" id="{97999032-45B0-4B0E-9E81-1FDEF4723964}"/>
+                <a16:creationId xmlns:a16="http://schemas.microsoft.com/office/drawing/2014/main" id="{6B3E904A-F0AB-4D59-A2E2-521E89F657E8}"/>
               </a:ext>
             </a:extLst>
           </p:cNvPr>
@@ -2007,7 +2007,7 @@
           <p:cNvPr id="2" name="Body">
             <a:extLst xmlns:a="http://schemas.openxmlformats.org/drawingml/2006/main">
               <a:ext uri="{FF2B5EF4-FFF2-40B4-BE49-F238E27FC236}">
-                <a16:creationId xmlns:a16="http://schemas.microsoft.com/office/drawing/2014/main" id="{4D6ACFBB-9AF4-45FF-9E02-3A98C456C6C0}"/>
+                <a16:creationId xmlns:a16="http://schemas.microsoft.com/office/drawing/2014/main" id="{48DBCBB7-8E7E-4A5F-8AF1-616ED5CAAB79}"/>
               </a:ext>
             </a:extLst>
           </p:cNvPr>
@@ -2253,7 +2253,7 @@
           <p:cNvPr id="4" name="Title">
             <a:extLst xmlns:a="http://schemas.openxmlformats.org/drawingml/2006/main">
               <a:ext uri="{FF2B5EF4-FFF2-40B4-BE49-F238E27FC236}">
-                <a16:creationId xmlns:a16="http://schemas.microsoft.com/office/drawing/2014/main" id="{5B803A73-BC89-4CEF-B7A6-E33B91109C58}"/>
+                <a16:creationId xmlns:a16="http://schemas.microsoft.com/office/drawing/2014/main" id="{29DA731F-9160-4F88-AB8E-EACD81787281}"/>
               </a:ext>
             </a:extLst>
           </p:cNvPr>
@@ -2482,7 +2482,7 @@
           <p:cNvPr id="2" name="Left column">
             <a:extLst xmlns:a="http://schemas.openxmlformats.org/drawingml/2006/main">
               <a:ext uri="{FF2B5EF4-FFF2-40B4-BE49-F238E27FC236}">
-                <a16:creationId xmlns:a16="http://schemas.microsoft.com/office/drawing/2014/main" id="{6A78465C-F668-4456-92B0-2668A9B054AB}"/>
+                <a16:creationId xmlns:a16="http://schemas.microsoft.com/office/drawing/2014/main" id="{DFC1092B-4029-4756-A426-6A9EF650145F}"/>
               </a:ext>
             </a:extLst>
           </p:cNvPr>
@@ -2711,7 +2711,7 @@
           <p:cNvPr id="3" name="Right column">
             <a:extLst xmlns:a="http://schemas.openxmlformats.org/drawingml/2006/main">
               <a:ext uri="{FF2B5EF4-FFF2-40B4-BE49-F238E27FC236}">
-                <a16:creationId xmlns:a16="http://schemas.microsoft.com/office/drawing/2014/main" id="{DBDD97E6-52CF-4A30-A742-48B94059FAA3}"/>
+                <a16:creationId xmlns:a16="http://schemas.microsoft.com/office/drawing/2014/main" id="{4CC6A7D0-BDA5-4EF7-93E5-DA76049E5E0D}"/>
               </a:ext>
             </a:extLst>
           </p:cNvPr>
@@ -2957,7 +2957,7 @@
           <p:cNvPr id="3" name="Title">
             <a:extLst xmlns:a="http://schemas.openxmlformats.org/drawingml/2006/main">
               <a:ext uri="{FF2B5EF4-FFF2-40B4-BE49-F238E27FC236}">
-                <a16:creationId xmlns:a16="http://schemas.microsoft.com/office/drawing/2014/main" id="{DF57B1E5-6FC8-4649-858C-EC6E15A3DD3C}"/>
+                <a16:creationId xmlns:a16="http://schemas.microsoft.com/office/drawing/2014/main" id="{DBB11AFB-0500-45A0-9837-F41B1EC904A5}"/>
               </a:ext>
             </a:extLst>
           </p:cNvPr>
@@ -3186,7 +3186,7 @@
           <p:cNvPr id="2" name="Left column">
             <a:extLst xmlns:a="http://schemas.openxmlformats.org/drawingml/2006/main">
               <a:ext uri="{FF2B5EF4-FFF2-40B4-BE49-F238E27FC236}">
-                <a16:creationId xmlns:a16="http://schemas.microsoft.com/office/drawing/2014/main" id="{0C7A60D8-27EB-4685-BCFD-F5CB2CAD313F}"/>
+                <a16:creationId xmlns:a16="http://schemas.microsoft.com/office/drawing/2014/main" id="{FE5F0590-18B1-4DA5-8197-1B0B91E7E976}"/>
               </a:ext>
             </a:extLst>
           </p:cNvPr>
@@ -3453,12 +3453,12 @@
   </p:cSld>
   <p:clrMap bg1="lt1" tx1="dk1" bg2="lt2" tx2="dk2" accent1="accent1" accent2="accent2" accent3="accent3" accent4="accent4" accent5="accent5" accent6="accent6" hlink="hlink" folHlink="folHlink"/>
   <p:sldLayoutIdLst>
-    <p:sldLayoutId xmlns:r="http://schemas.openxmlformats.org/officeDocument/2006/relationships" id="2147483649" r:id="R8d90905768bf4557"/>
-    <p:sldLayoutId xmlns:r="http://schemas.openxmlformats.org/officeDocument/2006/relationships" id="2147483650" r:id="R2492690f9d5b493e"/>
-    <p:sldLayoutId xmlns:r="http://schemas.openxmlformats.org/officeDocument/2006/relationships" id="2147483651" r:id="Reb7654282796428c"/>
-    <p:sldLayoutId xmlns:r="http://schemas.openxmlformats.org/officeDocument/2006/relationships" id="2147483652" r:id="Ra29127b75e8f4b32"/>
-    <p:sldLayoutId xmlns:r="http://schemas.openxmlformats.org/officeDocument/2006/relationships" id="2147483653" r:id="Rac71ec33b8094aa9"/>
-    <p:sldLayoutId xmlns:r="http://schemas.openxmlformats.org/officeDocument/2006/relationships" id="2147483654" r:id="Rfdf8ab537bdd4622"/>
+    <p:sldLayoutId xmlns:r="http://schemas.openxmlformats.org/officeDocument/2006/relationships" id="2147483649" r:id="Rac11a19e0b664dd3"/>
+    <p:sldLayoutId xmlns:r="http://schemas.openxmlformats.org/officeDocument/2006/relationships" id="2147483650" r:id="Rdbaea6fb16d94fea"/>
+    <p:sldLayoutId xmlns:r="http://schemas.openxmlformats.org/officeDocument/2006/relationships" id="2147483651" r:id="R12da0f92c5ee4059"/>
+    <p:sldLayoutId xmlns:r="http://schemas.openxmlformats.org/officeDocument/2006/relationships" id="2147483652" r:id="Rd6ede696fe24412d"/>
+    <p:sldLayoutId xmlns:r="http://schemas.openxmlformats.org/officeDocument/2006/relationships" id="2147483653" r:id="R9f037d8814d14a95"/>
+    <p:sldLayoutId xmlns:r="http://schemas.openxmlformats.org/officeDocument/2006/relationships" id="2147483654" r:id="R274caf232fe44339"/>
   </p:sldLayoutIdLst>
   <p:txStyles>
     <p:titleStyle>
@@ -4006,10 +4006,10 @@
       </p:grpSpPr>
       <p:sp>
         <p:nvSpPr>
-          <p:cNvPr id="16" name="">
+          <p:cNvPr id="14" name="">
             <a:extLst xmlns:a="http://schemas.openxmlformats.org/drawingml/2006/main">
               <a:ext uri="{FF2B5EF4-FFF2-40B4-BE49-F238E27FC236}">
-                <a16:creationId xmlns:a16="http://schemas.microsoft.com/office/drawing/2014/main" id="{87D73DE0-0221-447E-A096-98647F519443}"/>
+                <a16:creationId xmlns:a16="http://schemas.microsoft.com/office/drawing/2014/main" id="{F072CF56-01BB-4C7C-8BBE-F15A285142A5}"/>
               </a:ext>
             </a:extLst>
           </p:cNvPr>
@@ -4040,7 +4040,7 @@
           <p:cNvPr id="2" name="">
             <a:extLst xmlns:a="http://schemas.openxmlformats.org/drawingml/2006/main">
               <a:ext uri="{FF2B5EF4-FFF2-40B4-BE49-F238E27FC236}">
-                <a16:creationId xmlns:a16="http://schemas.microsoft.com/office/drawing/2014/main" id="{73A533E0-F726-48F3-83FF-9EB9AC4AAEBE}"/>
+                <a16:creationId xmlns:a16="http://schemas.microsoft.com/office/drawing/2014/main" id="{82D0BB3E-0223-43E0-A93B-380A7E961048}"/>
               </a:ext>
             </a:extLst>
           </p:cNvPr>
@@ -4161,7 +4161,7 @@
           <p:cNvPr id="3" name="">
             <a:extLst xmlns:a="http://schemas.openxmlformats.org/drawingml/2006/main">
               <a:ext uri="{FF2B5EF4-FFF2-40B4-BE49-F238E27FC236}">
-                <a16:creationId xmlns:a16="http://schemas.microsoft.com/office/drawing/2014/main" id="{6761EBB2-C166-4269-92DF-3379582CA5CA}"/>
+                <a16:creationId xmlns:a16="http://schemas.microsoft.com/office/drawing/2014/main" id="{A83770B4-17AF-409D-AE77-93AC0EC414F2}"/>
               </a:ext>
             </a:extLst>
           </p:cNvPr>
@@ -4299,7 +4299,7 @@
           <p:cNvPr id="4" name="">
             <a:extLst xmlns:a="http://schemas.openxmlformats.org/drawingml/2006/main">
               <a:ext uri="{FF2B5EF4-FFF2-40B4-BE49-F238E27FC236}">
-                <a16:creationId xmlns:a16="http://schemas.microsoft.com/office/drawing/2014/main" id="{9630714B-8EBE-41DE-80D4-A79D5CFA4A88}"/>
+                <a16:creationId xmlns:a16="http://schemas.microsoft.com/office/drawing/2014/main" id="{50EEAD4F-F177-4C95-87BE-0CBE8873D33E}"/>
               </a:ext>
             </a:extLst>
           </p:cNvPr>
@@ -4420,7 +4420,7 @@
           <p:cNvPr id="5" name="">
             <a:extLst xmlns:a="http://schemas.openxmlformats.org/drawingml/2006/main">
               <a:ext uri="{FF2B5EF4-FFF2-40B4-BE49-F238E27FC236}">
-                <a16:creationId xmlns:a16="http://schemas.microsoft.com/office/drawing/2014/main" id="{D10F5182-3936-4E76-84F0-C52DF938A06D}"/>
+                <a16:creationId xmlns:a16="http://schemas.microsoft.com/office/drawing/2014/main" id="{A6A0A215-B489-4DAA-B467-D265116F17F8}"/>
               </a:ext>
             </a:extLst>
           </p:cNvPr>
@@ -4451,249 +4451,7 @@
           <p:cNvPr id="6" name="">
             <a:extLst xmlns:a="http://schemas.openxmlformats.org/drawingml/2006/main">
               <a:ext uri="{FF2B5EF4-FFF2-40B4-BE49-F238E27FC236}">
-                <a16:creationId xmlns:a16="http://schemas.microsoft.com/office/drawing/2014/main" id="{F35984AF-A86C-4BE6-847A-E0504939C524}"/>
-              </a:ext>
-            </a:extLst>
-          </p:cNvPr>
-          <p:cNvSpPr>
-            <a:spLocks xmlns:a="http://schemas.openxmlformats.org/drawingml/2006/main" noGrp="1"/>
-          </p:cNvSpPr>
-          <p:nvPr/>
-        </p:nvSpPr>
-        <p:spPr>
-          <a:xfrm xmlns:a="http://schemas.openxmlformats.org/drawingml/2006/main">
-            <a:off x="800100" y="4810125"/>
-            <a:ext cx="6477000" cy="323850"/>
-          </a:xfrm>
-          <a:prstGeom xmlns:a="http://schemas.openxmlformats.org/drawingml/2006/main" prst="rect">
-            <a:avLst/>
-          </a:prstGeom>
-          <a:noFill xmlns:a="http://schemas.openxmlformats.org/drawingml/2006/main"/>
-          <a:ln xmlns:a="http://schemas.openxmlformats.org/drawingml/2006/main" w="0">
-            <a:noFill/>
-            <a:prstDash val="solid"/>
-          </a:ln>
-        </p:spPr>
-        <p:txBody>
-          <a:bodyPr xmlns:a="http://schemas.openxmlformats.org/drawingml/2006/main" lIns="38100" tIns="19050" rIns="38100" bIns="19050" anchor="ctr"/>
-          <a:lstStyle xmlns:a="http://schemas.openxmlformats.org/drawingml/2006/main">
-            <a:defPPr algn="l">
-              <a:defRPr sz="1500" b="0">
-                <a:solidFill>
-                  <a:srgbClr val="D7E4EC"/>
-                </a:solidFill>
-              </a:defRPr>
-            </a:defPPr>
-            <a:lvl1pPr algn="l">
-              <a:defRPr sz="1500" b="0">
-                <a:solidFill>
-                  <a:srgbClr val="D7E4EC"/>
-                </a:solidFill>
-              </a:defRPr>
-            </a:lvl1pPr>
-            <a:lvl2pPr algn="l">
-              <a:defRPr sz="1500" b="0">
-                <a:solidFill>
-                  <a:srgbClr val="D7E4EC"/>
-                </a:solidFill>
-              </a:defRPr>
-            </a:lvl2pPr>
-            <a:lvl3pPr algn="l">
-              <a:defRPr sz="1500" b="0">
-                <a:solidFill>
-                  <a:srgbClr val="D7E4EC"/>
-                </a:solidFill>
-              </a:defRPr>
-            </a:lvl3pPr>
-            <a:lvl4pPr algn="l">
-              <a:defRPr sz="1500" b="0">
-                <a:solidFill>
-                  <a:srgbClr val="D7E4EC"/>
-                </a:solidFill>
-              </a:defRPr>
-            </a:lvl4pPr>
-            <a:lvl5pPr algn="l">
-              <a:defRPr sz="1500" b="0">
-                <a:solidFill>
-                  <a:srgbClr val="D7E4EC"/>
-                </a:solidFill>
-              </a:defRPr>
-            </a:lvl5pPr>
-            <a:lvl6pPr algn="l">
-              <a:defRPr sz="1500" b="0">
-                <a:solidFill>
-                  <a:srgbClr val="D7E4EC"/>
-                </a:solidFill>
-              </a:defRPr>
-            </a:lvl6pPr>
-            <a:lvl7pPr algn="l">
-              <a:defRPr sz="1500" b="0">
-                <a:solidFill>
-                  <a:srgbClr val="D7E4EC"/>
-                </a:solidFill>
-              </a:defRPr>
-            </a:lvl7pPr>
-            <a:lvl8pPr algn="l">
-              <a:defRPr sz="1500" b="0">
-                <a:solidFill>
-                  <a:srgbClr val="D7E4EC"/>
-                </a:solidFill>
-              </a:defRPr>
-            </a:lvl8pPr>
-            <a:lvl9pPr algn="l">
-              <a:defRPr sz="1500" b="0">
-                <a:solidFill>
-                  <a:srgbClr val="D7E4EC"/>
-                </a:solidFill>
-              </a:defRPr>
-            </a:lvl9pPr>
-          </a:lstStyle>
-          <a:p xmlns:a="http://schemas.openxmlformats.org/drawingml/2006/main">
-            <a:pPr algn="l">
-              <a:defRPr sz="1500" b="0">
-                <a:solidFill>
-                  <a:srgbClr val="D7E4EC"/>
-                </a:solidFill>
-              </a:defRPr>
-            </a:pPr>
-            <a:r>
-              <a:rPr sz="1500" b="0">
-                <a:solidFill>
-                  <a:srgbClr val="D7E4EC"/>
-                </a:solidFill>
-              </a:rPr>
-              <a:t>Security design  |  27 October 2026</a:t>
-            </a:r>
-          </a:p>
-        </p:txBody>
-      </p:sp>
-      <p:sp>
-        <p:nvSpPr>
-          <p:cNvPr id="7" name="">
-            <a:extLst xmlns:a="http://schemas.openxmlformats.org/drawingml/2006/main">
-              <a:ext uri="{FF2B5EF4-FFF2-40B4-BE49-F238E27FC236}">
-                <a16:creationId xmlns:a16="http://schemas.microsoft.com/office/drawing/2014/main" id="{D48C0481-391B-4FD7-A3DC-D6443C284426}"/>
-              </a:ext>
-            </a:extLst>
-          </p:cNvPr>
-          <p:cNvSpPr>
-            <a:spLocks xmlns:a="http://schemas.openxmlformats.org/drawingml/2006/main" noGrp="1"/>
-          </p:cNvSpPr>
-          <p:nvPr/>
-        </p:nvSpPr>
-        <p:spPr>
-          <a:xfrm xmlns:a="http://schemas.openxmlformats.org/drawingml/2006/main">
-            <a:off x="800100" y="5238750"/>
-            <a:ext cx="3810000" cy="266700"/>
-          </a:xfrm>
-          <a:prstGeom xmlns:a="http://schemas.openxmlformats.org/drawingml/2006/main" prst="rect">
-            <a:avLst/>
-          </a:prstGeom>
-          <a:noFill xmlns:a="http://schemas.openxmlformats.org/drawingml/2006/main"/>
-          <a:ln xmlns:a="http://schemas.openxmlformats.org/drawingml/2006/main" w="0">
-            <a:noFill/>
-            <a:prstDash val="solid"/>
-          </a:ln>
-        </p:spPr>
-        <p:txBody>
-          <a:bodyPr xmlns:a="http://schemas.openxmlformats.org/drawingml/2006/main" lIns="38100" tIns="19050" rIns="38100" bIns="19050" anchor="ctr"/>
-          <a:lstStyle xmlns:a="http://schemas.openxmlformats.org/drawingml/2006/main">
-            <a:defPPr algn="l">
-              <a:defRPr sz="1275" b="1">
-                <a:solidFill>
-                  <a:srgbClr val="8FE3D4"/>
-                </a:solidFill>
-              </a:defRPr>
-            </a:defPPr>
-            <a:lvl1pPr algn="l">
-              <a:defRPr sz="1275" b="1">
-                <a:solidFill>
-                  <a:srgbClr val="8FE3D4"/>
-                </a:solidFill>
-              </a:defRPr>
-            </a:lvl1pPr>
-            <a:lvl2pPr algn="l">
-              <a:defRPr sz="1275" b="1">
-                <a:solidFill>
-                  <a:srgbClr val="8FE3D4"/>
-                </a:solidFill>
-              </a:defRPr>
-            </a:lvl2pPr>
-            <a:lvl3pPr algn="l">
-              <a:defRPr sz="1275" b="1">
-                <a:solidFill>
-                  <a:srgbClr val="8FE3D4"/>
-                </a:solidFill>
-              </a:defRPr>
-            </a:lvl3pPr>
-            <a:lvl4pPr algn="l">
-              <a:defRPr sz="1275" b="1">
-                <a:solidFill>
-                  <a:srgbClr val="8FE3D4"/>
-                </a:solidFill>
-              </a:defRPr>
-            </a:lvl4pPr>
-            <a:lvl5pPr algn="l">
-              <a:defRPr sz="1275" b="1">
-                <a:solidFill>
-                  <a:srgbClr val="8FE3D4"/>
-                </a:solidFill>
-              </a:defRPr>
-            </a:lvl5pPr>
-            <a:lvl6pPr algn="l">
-              <a:defRPr sz="1275" b="1">
-                <a:solidFill>
-                  <a:srgbClr val="8FE3D4"/>
-                </a:solidFill>
-              </a:defRPr>
-            </a:lvl6pPr>
-            <a:lvl7pPr algn="l">
-              <a:defRPr sz="1275" b="1">
-                <a:solidFill>
-                  <a:srgbClr val="8FE3D4"/>
-                </a:solidFill>
-              </a:defRPr>
-            </a:lvl7pPr>
-            <a:lvl8pPr algn="l">
-              <a:defRPr sz="1275" b="1">
-                <a:solidFill>
-                  <a:srgbClr val="8FE3D4"/>
-                </a:solidFill>
-              </a:defRPr>
-            </a:lvl8pPr>
-            <a:lvl9pPr algn="l">
-              <a:defRPr sz="1275" b="1">
-                <a:solidFill>
-                  <a:srgbClr val="8FE3D4"/>
-                </a:solidFill>
-              </a:defRPr>
-            </a:lvl9pPr>
-          </a:lstStyle>
-          <a:p xmlns:a="http://schemas.openxmlformats.org/drawingml/2006/main">
-            <a:pPr algn="l">
-              <a:defRPr sz="1275" b="1">
-                <a:solidFill>
-                  <a:srgbClr val="8FE3D4"/>
-                </a:solidFill>
-              </a:defRPr>
-            </a:pPr>
-            <a:r>
-              <a:rPr sz="1275" b="1">
-                <a:solidFill>
-                  <a:srgbClr val="8FE3D4"/>
-                </a:solidFill>
-              </a:rPr>
-              <a:t>10 minute presentation</a:t>
-            </a:r>
-          </a:p>
-        </p:txBody>
-      </p:sp>
-      <p:sp>
-        <p:nvSpPr>
-          <p:cNvPr id="8" name="">
-            <a:extLst xmlns:a="http://schemas.openxmlformats.org/drawingml/2006/main">
-              <a:ext uri="{FF2B5EF4-FFF2-40B4-BE49-F238E27FC236}">
-                <a16:creationId xmlns:a16="http://schemas.microsoft.com/office/drawing/2014/main" id="{FBA24C02-8DAB-4246-B3FF-D66965039D2E}"/>
+                <a16:creationId xmlns:a16="http://schemas.microsoft.com/office/drawing/2014/main" id="{36D53813-97B4-4B92-9194-C3531D0D38AE}"/>
               </a:ext>
             </a:extLst>
           </p:cNvPr>
@@ -4725,10 +4483,10 @@
       </p:sp>
       <p:sp>
         <p:nvSpPr>
-          <p:cNvPr id="9" name="">
+          <p:cNvPr id="7" name="">
             <a:extLst xmlns:a="http://schemas.openxmlformats.org/drawingml/2006/main">
               <a:ext uri="{FF2B5EF4-FFF2-40B4-BE49-F238E27FC236}">
-                <a16:creationId xmlns:a16="http://schemas.microsoft.com/office/drawing/2014/main" id="{C4BF14AD-6DA4-47C0-8E9B-E2BE2173D3D9}"/>
+                <a16:creationId xmlns:a16="http://schemas.microsoft.com/office/drawing/2014/main" id="{3E13142C-4D43-4257-B0B0-D3D135126253}"/>
               </a:ext>
             </a:extLst>
           </p:cNvPr>
@@ -4846,10 +4604,10 @@
       </p:sp>
       <p:sp>
         <p:nvSpPr>
-          <p:cNvPr id="10" name="">
+          <p:cNvPr id="8" name="">
             <a:extLst xmlns:a="http://schemas.openxmlformats.org/drawingml/2006/main">
               <a:ext uri="{FF2B5EF4-FFF2-40B4-BE49-F238E27FC236}">
-                <a16:creationId xmlns:a16="http://schemas.microsoft.com/office/drawing/2014/main" id="{378B3D21-C11F-4E9A-A4FB-11E8B5A8A7D4}"/>
+                <a16:creationId xmlns:a16="http://schemas.microsoft.com/office/drawing/2014/main" id="{2333AB20-9451-471F-9DC1-266B4F050697}"/>
               </a:ext>
             </a:extLst>
           </p:cNvPr>
@@ -4881,10 +4639,10 @@
       </p:sp>
       <p:sp>
         <p:nvSpPr>
-          <p:cNvPr id="11" name="">
+          <p:cNvPr id="9" name="">
             <a:extLst xmlns:a="http://schemas.openxmlformats.org/drawingml/2006/main">
               <a:ext uri="{FF2B5EF4-FFF2-40B4-BE49-F238E27FC236}">
-                <a16:creationId xmlns:a16="http://schemas.microsoft.com/office/drawing/2014/main" id="{672636D1-10AE-4F39-9EFA-59BEB40F24CB}"/>
+                <a16:creationId xmlns:a16="http://schemas.microsoft.com/office/drawing/2014/main" id="{511CE5F8-177D-47E5-94DC-F52D76D94B61}"/>
               </a:ext>
             </a:extLst>
           </p:cNvPr>
@@ -5002,10 +4760,10 @@
       </p:sp>
       <p:sp>
         <p:nvSpPr>
-          <p:cNvPr id="12" name="">
+          <p:cNvPr id="10" name="">
             <a:extLst xmlns:a="http://schemas.openxmlformats.org/drawingml/2006/main">
               <a:ext uri="{FF2B5EF4-FFF2-40B4-BE49-F238E27FC236}">
-                <a16:creationId xmlns:a16="http://schemas.microsoft.com/office/drawing/2014/main" id="{60A3840D-B851-415B-9E20-928AC84CAF94}"/>
+                <a16:creationId xmlns:a16="http://schemas.microsoft.com/office/drawing/2014/main" id="{35DA1D55-50B7-488B-9508-8F6307381B0F}"/>
               </a:ext>
             </a:extLst>
           </p:cNvPr>
@@ -5037,10 +4795,10 @@
       </p:sp>
       <p:sp>
         <p:nvSpPr>
-          <p:cNvPr id="13" name="">
+          <p:cNvPr id="11" name="">
             <a:extLst xmlns:a="http://schemas.openxmlformats.org/drawingml/2006/main">
               <a:ext uri="{FF2B5EF4-FFF2-40B4-BE49-F238E27FC236}">
-                <a16:creationId xmlns:a16="http://schemas.microsoft.com/office/drawing/2014/main" id="{C1AC14F8-4784-44AD-9E9F-D5AD275EE2EC}"/>
+                <a16:creationId xmlns:a16="http://schemas.microsoft.com/office/drawing/2014/main" id="{D8CA37C8-0E31-43ED-A174-A56EA1145E59}"/>
               </a:ext>
             </a:extLst>
           </p:cNvPr>
@@ -5158,10 +4916,10 @@
       </p:sp>
       <p:sp>
         <p:nvSpPr>
-          <p:cNvPr id="14" name="">
+          <p:cNvPr id="12" name="">
             <a:extLst xmlns:a="http://schemas.openxmlformats.org/drawingml/2006/main">
               <a:ext uri="{FF2B5EF4-FFF2-40B4-BE49-F238E27FC236}">
-                <a16:creationId xmlns:a16="http://schemas.microsoft.com/office/drawing/2014/main" id="{1680D6E7-DC64-4DA0-8DAC-36FC89122FF9}"/>
+                <a16:creationId xmlns:a16="http://schemas.microsoft.com/office/drawing/2014/main" id="{FC46C2A6-5439-4041-B505-A3C0656FAC0D}"/>
               </a:ext>
             </a:extLst>
           </p:cNvPr>
@@ -5189,10 +4947,10 @@
       </p:sp>
       <p:sp>
         <p:nvSpPr>
-          <p:cNvPr id="15" name="">
+          <p:cNvPr id="13" name="">
             <a:extLst xmlns:a="http://schemas.openxmlformats.org/drawingml/2006/main">
               <a:ext uri="{FF2B5EF4-FFF2-40B4-BE49-F238E27FC236}">
-                <a16:creationId xmlns:a16="http://schemas.microsoft.com/office/drawing/2014/main" id="{905309E9-799E-47BB-A2D9-23A5DA907DCF}"/>
+                <a16:creationId xmlns:a16="http://schemas.microsoft.com/office/drawing/2014/main" id="{EFB917AF-8D67-4812-9C86-DBFEE1FBAE06}"/>
               </a:ext>
             </a:extLst>
           </p:cNvPr>
@@ -5221,7 +4979,7 @@
     </p:spTree>
     <p:extLst>
       <p:ext uri="{BB962C8B-B14F-4D97-AF65-F5344CB8AC3E}">
-        <p14:creationId xmlns:p14="http://schemas.microsoft.com/office/powerpoint/2010/main" val="871321086"/>
+        <p14:creationId xmlns:p14="http://schemas.microsoft.com/office/powerpoint/2010/main" val="1444127794"/>
       </p:ext>
     </p:extLst>
   </p:cSld>
@@ -5252,7 +5010,7 @@
           <p:cNvPr id="20" name="">
             <a:extLst xmlns:a="http://schemas.openxmlformats.org/drawingml/2006/main">
               <a:ext uri="{FF2B5EF4-FFF2-40B4-BE49-F238E27FC236}">
-                <a16:creationId xmlns:a16="http://schemas.microsoft.com/office/drawing/2014/main" id="{315E45E8-E01D-419F-80F2-D83C411A42C9}"/>
+                <a16:creationId xmlns:a16="http://schemas.microsoft.com/office/drawing/2014/main" id="{1E520155-C3BF-431E-BB0E-9D7A098F2FA2}"/>
               </a:ext>
             </a:extLst>
           </p:cNvPr>
@@ -5283,7 +5041,7 @@
           <p:cNvPr id="2" name="">
             <a:extLst xmlns:a="http://schemas.openxmlformats.org/drawingml/2006/main">
               <a:ext uri="{FF2B5EF4-FFF2-40B4-BE49-F238E27FC236}">
-                <a16:creationId xmlns:a16="http://schemas.microsoft.com/office/drawing/2014/main" id="{FF5BD75B-11F8-44F3-BB8E-1F5AB7872068}"/>
+                <a16:creationId xmlns:a16="http://schemas.microsoft.com/office/drawing/2014/main" id="{B1E6088D-1588-4E0D-8239-E768A89028D0}"/>
               </a:ext>
             </a:extLst>
           </p:cNvPr>
@@ -5404,7 +5162,7 @@
           <p:cNvPr id="3" name="">
             <a:extLst xmlns:a="http://schemas.openxmlformats.org/drawingml/2006/main">
               <a:ext uri="{FF2B5EF4-FFF2-40B4-BE49-F238E27FC236}">
-                <a16:creationId xmlns:a16="http://schemas.microsoft.com/office/drawing/2014/main" id="{327192A5-F4A8-4C09-B80B-32C9C0AF128A}"/>
+                <a16:creationId xmlns:a16="http://schemas.microsoft.com/office/drawing/2014/main" id="{1D36946E-28CF-41E2-80E9-953073F0DA49}"/>
               </a:ext>
             </a:extLst>
           </p:cNvPr>
@@ -5525,7 +5283,7 @@
           <p:cNvPr id="4" name="">
             <a:extLst xmlns:a="http://schemas.openxmlformats.org/drawingml/2006/main">
               <a:ext uri="{FF2B5EF4-FFF2-40B4-BE49-F238E27FC236}">
-                <a16:creationId xmlns:a16="http://schemas.microsoft.com/office/drawing/2014/main" id="{FE2D830A-7BD2-4403-9401-7A7E9B04744B}"/>
+                <a16:creationId xmlns:a16="http://schemas.microsoft.com/office/drawing/2014/main" id="{8F20D481-ADD4-4603-95BE-76501BC19464}"/>
               </a:ext>
             </a:extLst>
           </p:cNvPr>
@@ -5556,7 +5314,7 @@
           <p:cNvPr id="5" name="">
             <a:extLst xmlns:a="http://schemas.openxmlformats.org/drawingml/2006/main">
               <a:ext uri="{FF2B5EF4-FFF2-40B4-BE49-F238E27FC236}">
-                <a16:creationId xmlns:a16="http://schemas.microsoft.com/office/drawing/2014/main" id="{5E3B1EC1-19E6-47BD-80FD-EBB893735886}"/>
+                <a16:creationId xmlns:a16="http://schemas.microsoft.com/office/drawing/2014/main" id="{6536162F-7B99-44F7-84C1-FCB5A23DB228}"/>
               </a:ext>
             </a:extLst>
           </p:cNvPr>
@@ -5677,7 +5435,7 @@
           <p:cNvPr id="6" name="">
             <a:extLst xmlns:a="http://schemas.openxmlformats.org/drawingml/2006/main">
               <a:ext uri="{FF2B5EF4-FFF2-40B4-BE49-F238E27FC236}">
-                <a16:creationId xmlns:a16="http://schemas.microsoft.com/office/drawing/2014/main" id="{6A0FEB2A-55DB-4B20-B89D-EEB618390E0F}"/>
+                <a16:creationId xmlns:a16="http://schemas.microsoft.com/office/drawing/2014/main" id="{44FEB128-10DD-4AB4-B40D-DEDFDC75AAB7}"/>
               </a:ext>
             </a:extLst>
           </p:cNvPr>
@@ -5798,7 +5556,7 @@
           <p:cNvPr id="7" name="">
             <a:extLst xmlns:a="http://schemas.openxmlformats.org/drawingml/2006/main">
               <a:ext uri="{FF2B5EF4-FFF2-40B4-BE49-F238E27FC236}">
-                <a16:creationId xmlns:a16="http://schemas.microsoft.com/office/drawing/2014/main" id="{BE18D90A-3552-4250-A972-A6A5B0E55758}"/>
+                <a16:creationId xmlns:a16="http://schemas.microsoft.com/office/drawing/2014/main" id="{C5BE9BCF-F383-4510-BB13-04636CF1D52C}"/>
               </a:ext>
             </a:extLst>
           </p:cNvPr>
@@ -5919,7 +5677,7 @@
           <p:cNvPr id="8" name="">
             <a:extLst xmlns:a="http://schemas.openxmlformats.org/drawingml/2006/main">
               <a:ext uri="{FF2B5EF4-FFF2-40B4-BE49-F238E27FC236}">
-                <a16:creationId xmlns:a16="http://schemas.microsoft.com/office/drawing/2014/main" id="{8EE7EC6A-28D2-4261-B4FB-8E6FE4213505}"/>
+                <a16:creationId xmlns:a16="http://schemas.microsoft.com/office/drawing/2014/main" id="{E22C21FD-1ABF-4346-AE36-75C93AA5563F}"/>
               </a:ext>
             </a:extLst>
           </p:cNvPr>
@@ -6040,7 +5798,7 @@
           <p:cNvPr id="9" name="">
             <a:extLst xmlns:a="http://schemas.openxmlformats.org/drawingml/2006/main">
               <a:ext uri="{FF2B5EF4-FFF2-40B4-BE49-F238E27FC236}">
-                <a16:creationId xmlns:a16="http://schemas.microsoft.com/office/drawing/2014/main" id="{A2509C76-9D1E-4DD3-9D82-0AC4A949801A}"/>
+                <a16:creationId xmlns:a16="http://schemas.microsoft.com/office/drawing/2014/main" id="{D5917CDC-4394-4639-9738-70C7107F3A4E}"/>
               </a:ext>
             </a:extLst>
           </p:cNvPr>
@@ -6161,7 +5919,7 @@
           <p:cNvPr id="10" name="">
             <a:extLst xmlns:a="http://schemas.openxmlformats.org/drawingml/2006/main">
               <a:ext uri="{FF2B5EF4-FFF2-40B4-BE49-F238E27FC236}">
-                <a16:creationId xmlns:a16="http://schemas.microsoft.com/office/drawing/2014/main" id="{72324C85-6694-4702-9C8D-C5DBEFF8DE3B}"/>
+                <a16:creationId xmlns:a16="http://schemas.microsoft.com/office/drawing/2014/main" id="{1B6B0F3D-9131-414C-AEB1-88E47ECA4C4E}"/>
               </a:ext>
             </a:extLst>
           </p:cNvPr>
@@ -6282,7 +6040,7 @@
           <p:cNvPr id="11" name="">
             <a:extLst xmlns:a="http://schemas.openxmlformats.org/drawingml/2006/main">
               <a:ext uri="{FF2B5EF4-FFF2-40B4-BE49-F238E27FC236}">
-                <a16:creationId xmlns:a16="http://schemas.microsoft.com/office/drawing/2014/main" id="{5A965569-D7C6-4841-A4EB-57CAB92600F3}"/>
+                <a16:creationId xmlns:a16="http://schemas.microsoft.com/office/drawing/2014/main" id="{6F043F41-6057-4ABF-A06E-E81EDB431578}"/>
               </a:ext>
             </a:extLst>
           </p:cNvPr>
@@ -6403,7 +6161,7 @@
           <p:cNvPr id="12" name="">
             <a:extLst xmlns:a="http://schemas.openxmlformats.org/drawingml/2006/main">
               <a:ext uri="{FF2B5EF4-FFF2-40B4-BE49-F238E27FC236}">
-                <a16:creationId xmlns:a16="http://schemas.microsoft.com/office/drawing/2014/main" id="{1CA8C89C-785F-4F1E-9835-8E01633B1921}"/>
+                <a16:creationId xmlns:a16="http://schemas.microsoft.com/office/drawing/2014/main" id="{14089153-CD4D-45D1-BDCD-83E5681159D1}"/>
               </a:ext>
             </a:extLst>
           </p:cNvPr>
@@ -6438,7 +6196,7 @@
           <p:cNvPr id="13" name="">
             <a:extLst xmlns:a="http://schemas.openxmlformats.org/drawingml/2006/main">
               <a:ext uri="{FF2B5EF4-FFF2-40B4-BE49-F238E27FC236}">
-                <a16:creationId xmlns:a16="http://schemas.microsoft.com/office/drawing/2014/main" id="{8968D52B-5C6E-42A1-9699-17659C114B40}"/>
+                <a16:creationId xmlns:a16="http://schemas.microsoft.com/office/drawing/2014/main" id="{3910FF2A-3882-4D93-87D9-52E81D208F70}"/>
               </a:ext>
             </a:extLst>
           </p:cNvPr>
@@ -6576,7 +6334,7 @@
           <p:cNvPr id="14" name="">
             <a:extLst xmlns:a="http://schemas.openxmlformats.org/drawingml/2006/main">
               <a:ext uri="{FF2B5EF4-FFF2-40B4-BE49-F238E27FC236}">
-                <a16:creationId xmlns:a16="http://schemas.microsoft.com/office/drawing/2014/main" id="{2BC93137-FC92-4552-A677-0FAC3134A2F8}"/>
+                <a16:creationId xmlns:a16="http://schemas.microsoft.com/office/drawing/2014/main" id="{18EC5CB8-0221-4EB6-A3E3-CB8C10613E28}"/>
               </a:ext>
             </a:extLst>
           </p:cNvPr>
@@ -6611,7 +6369,7 @@
           <p:cNvPr id="15" name="">
             <a:extLst xmlns:a="http://schemas.openxmlformats.org/drawingml/2006/main">
               <a:ext uri="{FF2B5EF4-FFF2-40B4-BE49-F238E27FC236}">
-                <a16:creationId xmlns:a16="http://schemas.microsoft.com/office/drawing/2014/main" id="{254DDFF2-ACF8-4418-9259-1DF0D3358C09}"/>
+                <a16:creationId xmlns:a16="http://schemas.microsoft.com/office/drawing/2014/main" id="{EFCD8051-25BD-493F-9F2E-5C15E6986F96}"/>
               </a:ext>
             </a:extLst>
           </p:cNvPr>
@@ -6749,7 +6507,7 @@
           <p:cNvPr id="16" name="">
             <a:extLst xmlns:a="http://schemas.openxmlformats.org/drawingml/2006/main">
               <a:ext uri="{FF2B5EF4-FFF2-40B4-BE49-F238E27FC236}">
-                <a16:creationId xmlns:a16="http://schemas.microsoft.com/office/drawing/2014/main" id="{137E4263-2D4A-4E44-8F5E-E25D102F7C27}"/>
+                <a16:creationId xmlns:a16="http://schemas.microsoft.com/office/drawing/2014/main" id="{D924968B-6D61-4C35-8866-7FDF548B7E04}"/>
               </a:ext>
             </a:extLst>
           </p:cNvPr>
@@ -6784,7 +6542,7 @@
           <p:cNvPr id="17" name="">
             <a:extLst xmlns:a="http://schemas.openxmlformats.org/drawingml/2006/main">
               <a:ext uri="{FF2B5EF4-FFF2-40B4-BE49-F238E27FC236}">
-                <a16:creationId xmlns:a16="http://schemas.microsoft.com/office/drawing/2014/main" id="{0FEFCCA3-681F-4726-9B7E-0DE38E9869E8}"/>
+                <a16:creationId xmlns:a16="http://schemas.microsoft.com/office/drawing/2014/main" id="{34729722-D4E1-4912-8784-320808646F55}"/>
               </a:ext>
             </a:extLst>
           </p:cNvPr>
@@ -6922,7 +6680,7 @@
           <p:cNvPr id="18" name="">
             <a:extLst xmlns:a="http://schemas.openxmlformats.org/drawingml/2006/main">
               <a:ext uri="{FF2B5EF4-FFF2-40B4-BE49-F238E27FC236}">
-                <a16:creationId xmlns:a16="http://schemas.microsoft.com/office/drawing/2014/main" id="{3E6F7A3A-7AF6-4D58-A5B5-5A7D5B970EB9}"/>
+                <a16:creationId xmlns:a16="http://schemas.microsoft.com/office/drawing/2014/main" id="{E29996AB-456B-4442-AD34-1C8ACE0E09B7}"/>
               </a:ext>
             </a:extLst>
           </p:cNvPr>
@@ -7043,7 +6801,7 @@
           <p:cNvPr id="19" name="">
             <a:extLst xmlns:a="http://schemas.openxmlformats.org/drawingml/2006/main">
               <a:ext uri="{FF2B5EF4-FFF2-40B4-BE49-F238E27FC236}">
-                <a16:creationId xmlns:a16="http://schemas.microsoft.com/office/drawing/2014/main" id="{5FE7D804-F529-4050-B2EE-8E3E9293C531}"/>
+                <a16:creationId xmlns:a16="http://schemas.microsoft.com/office/drawing/2014/main" id="{BAFB0259-F68C-4893-BCF3-54B82BA4815B}"/>
               </a:ext>
             </a:extLst>
           </p:cNvPr>
@@ -7162,7 +6920,7 @@
     </p:spTree>
     <p:extLst>
       <p:ext uri="{BB962C8B-B14F-4D97-AF65-F5344CB8AC3E}">
-        <p14:creationId xmlns:p14="http://schemas.microsoft.com/office/powerpoint/2010/main" val="36978401"/>
+        <p14:creationId xmlns:p14="http://schemas.microsoft.com/office/powerpoint/2010/main" val="412416395"/>
       </p:ext>
     </p:extLst>
   </p:cSld>
@@ -7193,7 +6951,7 @@
           <p:cNvPr id="43" name="">
             <a:extLst xmlns:a="http://schemas.openxmlformats.org/drawingml/2006/main">
               <a:ext uri="{FF2B5EF4-FFF2-40B4-BE49-F238E27FC236}">
-                <a16:creationId xmlns:a16="http://schemas.microsoft.com/office/drawing/2014/main" id="{458FFB08-CC0D-4DF7-8343-E1962808F7DF}"/>
+                <a16:creationId xmlns:a16="http://schemas.microsoft.com/office/drawing/2014/main" id="{8924110B-FFFB-4CCB-9DEB-8044678FA1E9}"/>
               </a:ext>
             </a:extLst>
           </p:cNvPr>
@@ -7224,7 +6982,7 @@
           <p:cNvPr id="2" name="">
             <a:extLst xmlns:a="http://schemas.openxmlformats.org/drawingml/2006/main">
               <a:ext uri="{FF2B5EF4-FFF2-40B4-BE49-F238E27FC236}">
-                <a16:creationId xmlns:a16="http://schemas.microsoft.com/office/drawing/2014/main" id="{C2F0E3D5-0AA6-4B8D-BCB1-0D4FC5628DFC}"/>
+                <a16:creationId xmlns:a16="http://schemas.microsoft.com/office/drawing/2014/main" id="{53458CCB-443A-42B7-A94C-25144FC5BEDC}"/>
               </a:ext>
             </a:extLst>
           </p:cNvPr>
@@ -7345,7 +7103,7 @@
           <p:cNvPr id="3" name="">
             <a:extLst xmlns:a="http://schemas.openxmlformats.org/drawingml/2006/main">
               <a:ext uri="{FF2B5EF4-FFF2-40B4-BE49-F238E27FC236}">
-                <a16:creationId xmlns:a16="http://schemas.microsoft.com/office/drawing/2014/main" id="{6EF49B98-EEA9-4701-987A-9F2F3D93738A}"/>
+                <a16:creationId xmlns:a16="http://schemas.microsoft.com/office/drawing/2014/main" id="{E6E57A14-7133-4B3D-AF4F-0398B27599F7}"/>
               </a:ext>
             </a:extLst>
           </p:cNvPr>
@@ -7466,7 +7224,7 @@
           <p:cNvPr id="4" name="">
             <a:extLst xmlns:a="http://schemas.openxmlformats.org/drawingml/2006/main">
               <a:ext uri="{FF2B5EF4-FFF2-40B4-BE49-F238E27FC236}">
-                <a16:creationId xmlns:a16="http://schemas.microsoft.com/office/drawing/2014/main" id="{485A951D-3203-42D4-A8B9-DB144ED6238A}"/>
+                <a16:creationId xmlns:a16="http://schemas.microsoft.com/office/drawing/2014/main" id="{04AD83D0-64CE-45DF-AEFD-9F617FBAE6D1}"/>
               </a:ext>
             </a:extLst>
           </p:cNvPr>
@@ -7497,7 +7255,7 @@
           <p:cNvPr id="5" name="">
             <a:extLst xmlns:a="http://schemas.openxmlformats.org/drawingml/2006/main">
               <a:ext uri="{FF2B5EF4-FFF2-40B4-BE49-F238E27FC236}">
-                <a16:creationId xmlns:a16="http://schemas.microsoft.com/office/drawing/2014/main" id="{E4605D19-FAFC-4497-BF6C-5B137A372AC8}"/>
+                <a16:creationId xmlns:a16="http://schemas.microsoft.com/office/drawing/2014/main" id="{7D747AC9-EB31-4039-8E77-83D7E693812D}"/>
               </a:ext>
             </a:extLst>
           </p:cNvPr>
@@ -7618,7 +7376,7 @@
           <p:cNvPr id="6" name="">
             <a:extLst xmlns:a="http://schemas.openxmlformats.org/drawingml/2006/main">
               <a:ext uri="{FF2B5EF4-FFF2-40B4-BE49-F238E27FC236}">
-                <a16:creationId xmlns:a16="http://schemas.microsoft.com/office/drawing/2014/main" id="{71842B79-4B1D-4A0A-849A-3445F5F9F4A1}"/>
+                <a16:creationId xmlns:a16="http://schemas.microsoft.com/office/drawing/2014/main" id="{83DA5466-98EE-4454-AEB3-1C3E6E496D16}"/>
               </a:ext>
             </a:extLst>
           </p:cNvPr>
@@ -7739,7 +7497,7 @@
           <p:cNvPr id="7" name="">
             <a:extLst xmlns:a="http://schemas.openxmlformats.org/drawingml/2006/main">
               <a:ext uri="{FF2B5EF4-FFF2-40B4-BE49-F238E27FC236}">
-                <a16:creationId xmlns:a16="http://schemas.microsoft.com/office/drawing/2014/main" id="{A436E47F-AE93-46DC-B702-596C055B68B7}"/>
+                <a16:creationId xmlns:a16="http://schemas.microsoft.com/office/drawing/2014/main" id="{8F3E7B89-0497-425E-AE96-E7631E4FFA6C}"/>
               </a:ext>
             </a:extLst>
           </p:cNvPr>
@@ -7774,7 +7532,7 @@
           <p:cNvPr id="8" name="">
             <a:extLst xmlns:a="http://schemas.openxmlformats.org/drawingml/2006/main">
               <a:ext uri="{FF2B5EF4-FFF2-40B4-BE49-F238E27FC236}">
-                <a16:creationId xmlns:a16="http://schemas.microsoft.com/office/drawing/2014/main" id="{83250B8D-05DD-4CF3-9E76-E2561C6A53E9}"/>
+                <a16:creationId xmlns:a16="http://schemas.microsoft.com/office/drawing/2014/main" id="{B191CC39-CBCD-46FF-A7B9-C321970982E2}"/>
               </a:ext>
             </a:extLst>
           </p:cNvPr>
@@ -7912,7 +7670,7 @@
           <p:cNvPr id="9" name="">
             <a:extLst xmlns:a="http://schemas.openxmlformats.org/drawingml/2006/main">
               <a:ext uri="{FF2B5EF4-FFF2-40B4-BE49-F238E27FC236}">
-                <a16:creationId xmlns:a16="http://schemas.microsoft.com/office/drawing/2014/main" id="{A337A970-4E28-42BC-920E-DADF2FC72ED1}"/>
+                <a16:creationId xmlns:a16="http://schemas.microsoft.com/office/drawing/2014/main" id="{DEB67925-BC93-4AAE-9E9F-FFEEB898B1F3}"/>
               </a:ext>
             </a:extLst>
           </p:cNvPr>
@@ -7947,7 +7705,7 @@
           <p:cNvPr id="10" name="">
             <a:extLst xmlns:a="http://schemas.openxmlformats.org/drawingml/2006/main">
               <a:ext uri="{FF2B5EF4-FFF2-40B4-BE49-F238E27FC236}">
-                <a16:creationId xmlns:a16="http://schemas.microsoft.com/office/drawing/2014/main" id="{4FFE1378-56C9-45F1-BC39-3E7AE91A3D95}"/>
+                <a16:creationId xmlns:a16="http://schemas.microsoft.com/office/drawing/2014/main" id="{381E4D76-5838-41A2-8CC1-1D21268C8C89}"/>
               </a:ext>
             </a:extLst>
           </p:cNvPr>
@@ -8085,7 +7843,7 @@
           <p:cNvPr id="11" name="">
             <a:extLst xmlns:a="http://schemas.openxmlformats.org/drawingml/2006/main">
               <a:ext uri="{FF2B5EF4-FFF2-40B4-BE49-F238E27FC236}">
-                <a16:creationId xmlns:a16="http://schemas.microsoft.com/office/drawing/2014/main" id="{8281FD88-ABFD-4107-98C7-3789B9F354D8}"/>
+                <a16:creationId xmlns:a16="http://schemas.microsoft.com/office/drawing/2014/main" id="{06E489BB-534C-4E8D-BA94-4C90940245E1}"/>
               </a:ext>
             </a:extLst>
           </p:cNvPr>
@@ -8120,7 +7878,7 @@
           <p:cNvPr id="12" name="">
             <a:extLst xmlns:a="http://schemas.openxmlformats.org/drawingml/2006/main">
               <a:ext uri="{FF2B5EF4-FFF2-40B4-BE49-F238E27FC236}">
-                <a16:creationId xmlns:a16="http://schemas.microsoft.com/office/drawing/2014/main" id="{1875880B-FAE1-488B-8BE1-DCE0B757F044}"/>
+                <a16:creationId xmlns:a16="http://schemas.microsoft.com/office/drawing/2014/main" id="{68D83626-6189-4136-A0FA-E1427D2C5C74}"/>
               </a:ext>
             </a:extLst>
           </p:cNvPr>
@@ -8258,7 +8016,7 @@
           <p:cNvPr id="13" name="">
             <a:extLst xmlns:a="http://schemas.openxmlformats.org/drawingml/2006/main">
               <a:ext uri="{FF2B5EF4-FFF2-40B4-BE49-F238E27FC236}">
-                <a16:creationId xmlns:a16="http://schemas.microsoft.com/office/drawing/2014/main" id="{91906EE0-46F2-4310-AA35-C750E55C9DAF}"/>
+                <a16:creationId xmlns:a16="http://schemas.microsoft.com/office/drawing/2014/main" id="{1F775233-0767-49D0-806B-61F3C8EFB278}"/>
               </a:ext>
             </a:extLst>
           </p:cNvPr>
@@ -8293,7 +8051,7 @@
           <p:cNvPr id="14" name="">
             <a:extLst xmlns:a="http://schemas.openxmlformats.org/drawingml/2006/main">
               <a:ext uri="{FF2B5EF4-FFF2-40B4-BE49-F238E27FC236}">
-                <a16:creationId xmlns:a16="http://schemas.microsoft.com/office/drawing/2014/main" id="{09DBB9BF-DE60-4D13-930F-8143B05E4410}"/>
+                <a16:creationId xmlns:a16="http://schemas.microsoft.com/office/drawing/2014/main" id="{A322D98D-CFD3-4B2E-97AD-87AB705CD9D3}"/>
               </a:ext>
             </a:extLst>
           </p:cNvPr>
@@ -8414,7 +8172,7 @@
           <p:cNvPr id="15" name="">
             <a:extLst xmlns:a="http://schemas.openxmlformats.org/drawingml/2006/main">
               <a:ext uri="{FF2B5EF4-FFF2-40B4-BE49-F238E27FC236}">
-                <a16:creationId xmlns:a16="http://schemas.microsoft.com/office/drawing/2014/main" id="{F02116FF-79D6-4C5A-B0ED-EDCDFCC6B40D}"/>
+                <a16:creationId xmlns:a16="http://schemas.microsoft.com/office/drawing/2014/main" id="{AEACA2CB-751E-4C2C-B6C2-D709068E3930}"/>
               </a:ext>
             </a:extLst>
           </p:cNvPr>
@@ -8445,7 +8203,7 @@
           <p:cNvPr id="16" name="">
             <a:extLst xmlns:a="http://schemas.openxmlformats.org/drawingml/2006/main">
               <a:ext uri="{FF2B5EF4-FFF2-40B4-BE49-F238E27FC236}">
-                <a16:creationId xmlns:a16="http://schemas.microsoft.com/office/drawing/2014/main" id="{2F21A40E-2EA7-418F-9757-D90810B50CC9}"/>
+                <a16:creationId xmlns:a16="http://schemas.microsoft.com/office/drawing/2014/main" id="{AB3CA30B-1268-4794-A482-A6058F9B9FEA}"/>
               </a:ext>
             </a:extLst>
           </p:cNvPr>
@@ -8566,7 +8324,7 @@
           <p:cNvPr id="17" name="">
             <a:extLst xmlns:a="http://schemas.openxmlformats.org/drawingml/2006/main">
               <a:ext uri="{FF2B5EF4-FFF2-40B4-BE49-F238E27FC236}">
-                <a16:creationId xmlns:a16="http://schemas.microsoft.com/office/drawing/2014/main" id="{09CDA67F-A2C4-4F5F-92EC-ED927EF7A724}"/>
+                <a16:creationId xmlns:a16="http://schemas.microsoft.com/office/drawing/2014/main" id="{68C8BA95-E93C-467B-A618-DCD707A8D28A}"/>
               </a:ext>
             </a:extLst>
           </p:cNvPr>
@@ -8687,7 +8445,7 @@
           <p:cNvPr id="18" name="">
             <a:extLst xmlns:a="http://schemas.openxmlformats.org/drawingml/2006/main">
               <a:ext uri="{FF2B5EF4-FFF2-40B4-BE49-F238E27FC236}">
-                <a16:creationId xmlns:a16="http://schemas.microsoft.com/office/drawing/2014/main" id="{DDA17065-B18A-4927-9748-1230EB7B9AF6}"/>
+                <a16:creationId xmlns:a16="http://schemas.microsoft.com/office/drawing/2014/main" id="{472C5502-BE9C-4E09-A2FF-FA01C5AFCA9C}"/>
               </a:ext>
             </a:extLst>
           </p:cNvPr>
@@ -8718,7 +8476,7 @@
           <p:cNvPr id="19" name="">
             <a:extLst xmlns:a="http://schemas.openxmlformats.org/drawingml/2006/main">
               <a:ext uri="{FF2B5EF4-FFF2-40B4-BE49-F238E27FC236}">
-                <a16:creationId xmlns:a16="http://schemas.microsoft.com/office/drawing/2014/main" id="{1709CE88-FF2D-417B-9C83-199C51A2CB9A}"/>
+                <a16:creationId xmlns:a16="http://schemas.microsoft.com/office/drawing/2014/main" id="{35558B73-C0B6-487F-B538-154B6CCBDA86}"/>
               </a:ext>
             </a:extLst>
           </p:cNvPr>
@@ -8839,7 +8597,7 @@
           <p:cNvPr id="20" name="">
             <a:extLst xmlns:a="http://schemas.openxmlformats.org/drawingml/2006/main">
               <a:ext uri="{FF2B5EF4-FFF2-40B4-BE49-F238E27FC236}">
-                <a16:creationId xmlns:a16="http://schemas.microsoft.com/office/drawing/2014/main" id="{05E394BC-D2FF-46F8-994C-88CDA3ACF6F5}"/>
+                <a16:creationId xmlns:a16="http://schemas.microsoft.com/office/drawing/2014/main" id="{2C575B67-0973-407D-959B-60EDABF73ABA}"/>
               </a:ext>
             </a:extLst>
           </p:cNvPr>
@@ -8960,7 +8718,7 @@
           <p:cNvPr id="21" name="">
             <a:extLst xmlns:a="http://schemas.openxmlformats.org/drawingml/2006/main">
               <a:ext uri="{FF2B5EF4-FFF2-40B4-BE49-F238E27FC236}">
-                <a16:creationId xmlns:a16="http://schemas.microsoft.com/office/drawing/2014/main" id="{C6B607F8-523F-4017-89CB-F4E54706EB25}"/>
+                <a16:creationId xmlns:a16="http://schemas.microsoft.com/office/drawing/2014/main" id="{5C6AB369-1965-4F0B-AD67-59A4652204FC}"/>
               </a:ext>
             </a:extLst>
           </p:cNvPr>
@@ -8991,7 +8749,7 @@
           <p:cNvPr id="22" name="">
             <a:extLst xmlns:a="http://schemas.openxmlformats.org/drawingml/2006/main">
               <a:ext uri="{FF2B5EF4-FFF2-40B4-BE49-F238E27FC236}">
-                <a16:creationId xmlns:a16="http://schemas.microsoft.com/office/drawing/2014/main" id="{76BE3DC9-071B-480B-AC48-5C5E67CBF2B8}"/>
+                <a16:creationId xmlns:a16="http://schemas.microsoft.com/office/drawing/2014/main" id="{35481479-788F-450F-81D8-6C116165B336}"/>
               </a:ext>
             </a:extLst>
           </p:cNvPr>
@@ -9112,7 +8870,7 @@
           <p:cNvPr id="23" name="">
             <a:extLst xmlns:a="http://schemas.openxmlformats.org/drawingml/2006/main">
               <a:ext uri="{FF2B5EF4-FFF2-40B4-BE49-F238E27FC236}">
-                <a16:creationId xmlns:a16="http://schemas.microsoft.com/office/drawing/2014/main" id="{FBB41BED-533F-4F65-9E73-416BF3D57C82}"/>
+                <a16:creationId xmlns:a16="http://schemas.microsoft.com/office/drawing/2014/main" id="{9A368DFF-138C-48D4-8675-4BC64E23759F}"/>
               </a:ext>
             </a:extLst>
           </p:cNvPr>
@@ -9233,7 +8991,7 @@
           <p:cNvPr id="24" name="">
             <a:extLst xmlns:a="http://schemas.openxmlformats.org/drawingml/2006/main">
               <a:ext uri="{FF2B5EF4-FFF2-40B4-BE49-F238E27FC236}">
-                <a16:creationId xmlns:a16="http://schemas.microsoft.com/office/drawing/2014/main" id="{405B2197-3086-4634-A32B-FBDA2962D238}"/>
+                <a16:creationId xmlns:a16="http://schemas.microsoft.com/office/drawing/2014/main" id="{C4F90BA0-7C9E-478B-9397-9F00F614705E}"/>
               </a:ext>
             </a:extLst>
           </p:cNvPr>
@@ -9268,7 +9026,7 @@
           <p:cNvPr id="25" name="">
             <a:extLst xmlns:a="http://schemas.openxmlformats.org/drawingml/2006/main">
               <a:ext uri="{FF2B5EF4-FFF2-40B4-BE49-F238E27FC236}">
-                <a16:creationId xmlns:a16="http://schemas.microsoft.com/office/drawing/2014/main" id="{F882B0B8-C8BB-43BE-8F2E-8507E5106AFD}"/>
+                <a16:creationId xmlns:a16="http://schemas.microsoft.com/office/drawing/2014/main" id="{6F31BFE1-2ABB-4107-9884-2F7E4AB7FA7D}"/>
               </a:ext>
             </a:extLst>
           </p:cNvPr>
@@ -9406,7 +9164,7 @@
           <p:cNvPr id="26" name="">
             <a:extLst xmlns:a="http://schemas.openxmlformats.org/drawingml/2006/main">
               <a:ext uri="{FF2B5EF4-FFF2-40B4-BE49-F238E27FC236}">
-                <a16:creationId xmlns:a16="http://schemas.microsoft.com/office/drawing/2014/main" id="{C21C7B5D-B4E7-494C-A1C8-F7685432CEBF}"/>
+                <a16:creationId xmlns:a16="http://schemas.microsoft.com/office/drawing/2014/main" id="{E5E36CFC-619C-4C7D-97C5-EFCFEE9518F6}"/>
               </a:ext>
             </a:extLst>
           </p:cNvPr>
@@ -9437,7 +9195,7 @@
           <p:cNvPr id="27" name="">
             <a:extLst xmlns:a="http://schemas.openxmlformats.org/drawingml/2006/main">
               <a:ext uri="{FF2B5EF4-FFF2-40B4-BE49-F238E27FC236}">
-                <a16:creationId xmlns:a16="http://schemas.microsoft.com/office/drawing/2014/main" id="{4425CA62-C81F-47B7-9763-3F63229F98E6}"/>
+                <a16:creationId xmlns:a16="http://schemas.microsoft.com/office/drawing/2014/main" id="{5CEE767A-5CA8-4DC8-8C19-8D5789A19D42}"/>
               </a:ext>
             </a:extLst>
           </p:cNvPr>
@@ -9558,7 +9316,7 @@
           <p:cNvPr id="28" name="">
             <a:extLst xmlns:a="http://schemas.openxmlformats.org/drawingml/2006/main">
               <a:ext uri="{FF2B5EF4-FFF2-40B4-BE49-F238E27FC236}">
-                <a16:creationId xmlns:a16="http://schemas.microsoft.com/office/drawing/2014/main" id="{845A8AD0-95EC-479B-8EF4-C5509E130608}"/>
+                <a16:creationId xmlns:a16="http://schemas.microsoft.com/office/drawing/2014/main" id="{765475FD-5406-4535-A71E-D0B48CD18DB9}"/>
               </a:ext>
             </a:extLst>
           </p:cNvPr>
@@ -9593,7 +9351,7 @@
           <p:cNvPr id="29" name="">
             <a:extLst xmlns:a="http://schemas.openxmlformats.org/drawingml/2006/main">
               <a:ext uri="{FF2B5EF4-FFF2-40B4-BE49-F238E27FC236}">
-                <a16:creationId xmlns:a16="http://schemas.microsoft.com/office/drawing/2014/main" id="{98A79BFB-58B9-4BA1-9632-A7AFB817AF4E}"/>
+                <a16:creationId xmlns:a16="http://schemas.microsoft.com/office/drawing/2014/main" id="{D59043D1-6E2C-42F6-A729-3BAEB23A8B02}"/>
               </a:ext>
             </a:extLst>
           </p:cNvPr>
@@ -9731,7 +9489,7 @@
           <p:cNvPr id="30" name="">
             <a:extLst xmlns:a="http://schemas.openxmlformats.org/drawingml/2006/main">
               <a:ext uri="{FF2B5EF4-FFF2-40B4-BE49-F238E27FC236}">
-                <a16:creationId xmlns:a16="http://schemas.microsoft.com/office/drawing/2014/main" id="{6A9A2208-F36B-4179-800C-BDB833D52ABB}"/>
+                <a16:creationId xmlns:a16="http://schemas.microsoft.com/office/drawing/2014/main" id="{B0B41127-DE8A-4CA8-8EA7-5B18B9A7E311}"/>
               </a:ext>
             </a:extLst>
           </p:cNvPr>
@@ -9762,7 +9520,7 @@
           <p:cNvPr id="31" name="">
             <a:extLst xmlns:a="http://schemas.openxmlformats.org/drawingml/2006/main">
               <a:ext uri="{FF2B5EF4-FFF2-40B4-BE49-F238E27FC236}">
-                <a16:creationId xmlns:a16="http://schemas.microsoft.com/office/drawing/2014/main" id="{1165B0D8-FC56-4BE0-B2D3-A408B7FA9100}"/>
+                <a16:creationId xmlns:a16="http://schemas.microsoft.com/office/drawing/2014/main" id="{34511F28-85A6-4C4D-ADF2-F55EE6887587}"/>
               </a:ext>
             </a:extLst>
           </p:cNvPr>
@@ -9883,7 +9641,7 @@
           <p:cNvPr id="32" name="">
             <a:extLst xmlns:a="http://schemas.openxmlformats.org/drawingml/2006/main">
               <a:ext uri="{FF2B5EF4-FFF2-40B4-BE49-F238E27FC236}">
-                <a16:creationId xmlns:a16="http://schemas.microsoft.com/office/drawing/2014/main" id="{ECBDC470-34D7-4C5F-AC02-A75AA40CDACB}"/>
+                <a16:creationId xmlns:a16="http://schemas.microsoft.com/office/drawing/2014/main" id="{6661E749-3AAD-4D91-AE11-EA32C70EFCA4}"/>
               </a:ext>
             </a:extLst>
           </p:cNvPr>
@@ -9918,7 +9676,7 @@
           <p:cNvPr id="33" name="">
             <a:extLst xmlns:a="http://schemas.openxmlformats.org/drawingml/2006/main">
               <a:ext uri="{FF2B5EF4-FFF2-40B4-BE49-F238E27FC236}">
-                <a16:creationId xmlns:a16="http://schemas.microsoft.com/office/drawing/2014/main" id="{D1794DA9-4B12-4CF5-A594-C1713E494E3F}"/>
+                <a16:creationId xmlns:a16="http://schemas.microsoft.com/office/drawing/2014/main" id="{3CA1C2C8-802E-43E3-82EC-ECCA365DC7F4}"/>
               </a:ext>
             </a:extLst>
           </p:cNvPr>
@@ -10056,7 +9814,7 @@
           <p:cNvPr id="34" name="">
             <a:extLst xmlns:a="http://schemas.openxmlformats.org/drawingml/2006/main">
               <a:ext uri="{FF2B5EF4-FFF2-40B4-BE49-F238E27FC236}">
-                <a16:creationId xmlns:a16="http://schemas.microsoft.com/office/drawing/2014/main" id="{9F53B7A1-3B60-4056-A48C-CD4EA3C9DC6A}"/>
+                <a16:creationId xmlns:a16="http://schemas.microsoft.com/office/drawing/2014/main" id="{68BB35BC-88C8-4083-93A2-0424EF06AEC1}"/>
               </a:ext>
             </a:extLst>
           </p:cNvPr>
@@ -10087,7 +9845,7 @@
           <p:cNvPr id="35" name="">
             <a:extLst xmlns:a="http://schemas.openxmlformats.org/drawingml/2006/main">
               <a:ext uri="{FF2B5EF4-FFF2-40B4-BE49-F238E27FC236}">
-                <a16:creationId xmlns:a16="http://schemas.microsoft.com/office/drawing/2014/main" id="{5B977D3F-9E5B-486D-BBD4-ADCE9F59C3B7}"/>
+                <a16:creationId xmlns:a16="http://schemas.microsoft.com/office/drawing/2014/main" id="{DCCC6E0E-1548-4234-A5AD-D6AB829F3471}"/>
               </a:ext>
             </a:extLst>
           </p:cNvPr>
@@ -10208,7 +9966,7 @@
           <p:cNvPr id="36" name="">
             <a:extLst xmlns:a="http://schemas.openxmlformats.org/drawingml/2006/main">
               <a:ext uri="{FF2B5EF4-FFF2-40B4-BE49-F238E27FC236}">
-                <a16:creationId xmlns:a16="http://schemas.microsoft.com/office/drawing/2014/main" id="{8620AE9E-70D3-4B4B-9FC6-7CB1D29DAE89}"/>
+                <a16:creationId xmlns:a16="http://schemas.microsoft.com/office/drawing/2014/main" id="{2209A245-6554-46F4-B346-F3DC9F95B0DD}"/>
               </a:ext>
             </a:extLst>
           </p:cNvPr>
@@ -10243,7 +10001,7 @@
           <p:cNvPr id="37" name="">
             <a:extLst xmlns:a="http://schemas.openxmlformats.org/drawingml/2006/main">
               <a:ext uri="{FF2B5EF4-FFF2-40B4-BE49-F238E27FC236}">
-                <a16:creationId xmlns:a16="http://schemas.microsoft.com/office/drawing/2014/main" id="{55198DA5-2721-4EC3-8AA9-F16DB9D3F2EA}"/>
+                <a16:creationId xmlns:a16="http://schemas.microsoft.com/office/drawing/2014/main" id="{06D55953-EB4A-44A8-A79F-E4153D98CB5A}"/>
               </a:ext>
             </a:extLst>
           </p:cNvPr>
@@ -10381,7 +10139,7 @@
           <p:cNvPr id="38" name="">
             <a:extLst xmlns:a="http://schemas.openxmlformats.org/drawingml/2006/main">
               <a:ext uri="{FF2B5EF4-FFF2-40B4-BE49-F238E27FC236}">
-                <a16:creationId xmlns:a16="http://schemas.microsoft.com/office/drawing/2014/main" id="{F4FAB737-D007-4768-8941-439912CE5EC8}"/>
+                <a16:creationId xmlns:a16="http://schemas.microsoft.com/office/drawing/2014/main" id="{49D1CCD5-4AF7-45E6-817F-57D018A7E706}"/>
               </a:ext>
             </a:extLst>
           </p:cNvPr>
@@ -10412,7 +10170,7 @@
           <p:cNvPr id="39" name="">
             <a:extLst xmlns:a="http://schemas.openxmlformats.org/drawingml/2006/main">
               <a:ext uri="{FF2B5EF4-FFF2-40B4-BE49-F238E27FC236}">
-                <a16:creationId xmlns:a16="http://schemas.microsoft.com/office/drawing/2014/main" id="{86DC7C11-EE4C-42F5-BB68-2520A722B4B9}"/>
+                <a16:creationId xmlns:a16="http://schemas.microsoft.com/office/drawing/2014/main" id="{8E09ABF4-93F1-4384-B640-8EEC7828F075}"/>
               </a:ext>
             </a:extLst>
           </p:cNvPr>
@@ -10533,7 +10291,7 @@
           <p:cNvPr id="40" name="">
             <a:extLst xmlns:a="http://schemas.openxmlformats.org/drawingml/2006/main">
               <a:ext uri="{FF2B5EF4-FFF2-40B4-BE49-F238E27FC236}">
-                <a16:creationId xmlns:a16="http://schemas.microsoft.com/office/drawing/2014/main" id="{7BC2BC42-84FF-4AC5-A4C9-7F5A5BEE9B06}"/>
+                <a16:creationId xmlns:a16="http://schemas.microsoft.com/office/drawing/2014/main" id="{550AE320-31BE-4516-B313-8B947F74A5B4}"/>
               </a:ext>
             </a:extLst>
           </p:cNvPr>
@@ -10568,7 +10326,7 @@
           <p:cNvPr id="41" name="">
             <a:extLst xmlns:a="http://schemas.openxmlformats.org/drawingml/2006/main">
               <a:ext uri="{FF2B5EF4-FFF2-40B4-BE49-F238E27FC236}">
-                <a16:creationId xmlns:a16="http://schemas.microsoft.com/office/drawing/2014/main" id="{51304169-F224-48B5-BF56-73DFDA727F5F}"/>
+                <a16:creationId xmlns:a16="http://schemas.microsoft.com/office/drawing/2014/main" id="{4F36A227-E54C-47B3-B34C-98AF8CA922A9}"/>
               </a:ext>
             </a:extLst>
           </p:cNvPr>
@@ -10689,7 +10447,7 @@
           <p:cNvPr id="42" name="">
             <a:extLst xmlns:a="http://schemas.openxmlformats.org/drawingml/2006/main">
               <a:ext uri="{FF2B5EF4-FFF2-40B4-BE49-F238E27FC236}">
-                <a16:creationId xmlns:a16="http://schemas.microsoft.com/office/drawing/2014/main" id="{37B21FD4-C5C9-4BFB-9C3E-ECEE10442949}"/>
+                <a16:creationId xmlns:a16="http://schemas.microsoft.com/office/drawing/2014/main" id="{93CFC6B0-620E-4AD5-90D5-6F7FBC73EE4A}"/>
               </a:ext>
             </a:extLst>
           </p:cNvPr>
@@ -10808,7 +10566,7 @@
     </p:spTree>
     <p:extLst>
       <p:ext uri="{BB962C8B-B14F-4D97-AF65-F5344CB8AC3E}">
-        <p14:creationId xmlns:p14="http://schemas.microsoft.com/office/powerpoint/2010/main" val="320471365"/>
+        <p14:creationId xmlns:p14="http://schemas.microsoft.com/office/powerpoint/2010/main" val="1571170597"/>
       </p:ext>
     </p:extLst>
   </p:cSld>
@@ -10839,7 +10597,7 @@
           <p:cNvPr id="26" name="">
             <a:extLst xmlns:a="http://schemas.openxmlformats.org/drawingml/2006/main">
               <a:ext uri="{FF2B5EF4-FFF2-40B4-BE49-F238E27FC236}">
-                <a16:creationId xmlns:a16="http://schemas.microsoft.com/office/drawing/2014/main" id="{712B0381-C871-43CA-A00A-038F84DF4343}"/>
+                <a16:creationId xmlns:a16="http://schemas.microsoft.com/office/drawing/2014/main" id="{26734152-0F87-41D9-91F7-5728561DE569}"/>
               </a:ext>
             </a:extLst>
           </p:cNvPr>
@@ -10870,7 +10628,7 @@
           <p:cNvPr id="2" name="">
             <a:extLst xmlns:a="http://schemas.openxmlformats.org/drawingml/2006/main">
               <a:ext uri="{FF2B5EF4-FFF2-40B4-BE49-F238E27FC236}">
-                <a16:creationId xmlns:a16="http://schemas.microsoft.com/office/drawing/2014/main" id="{D01B0814-08CE-457C-8F92-F18BA7416BDE}"/>
+                <a16:creationId xmlns:a16="http://schemas.microsoft.com/office/drawing/2014/main" id="{55A8DD63-E905-4F20-8065-D08F71AEAAB7}"/>
               </a:ext>
             </a:extLst>
           </p:cNvPr>
@@ -10991,7 +10749,7 @@
           <p:cNvPr id="3" name="">
             <a:extLst xmlns:a="http://schemas.openxmlformats.org/drawingml/2006/main">
               <a:ext uri="{FF2B5EF4-FFF2-40B4-BE49-F238E27FC236}">
-                <a16:creationId xmlns:a16="http://schemas.microsoft.com/office/drawing/2014/main" id="{9DA24F49-5128-4B7E-8E9D-229DFE8F806E}"/>
+                <a16:creationId xmlns:a16="http://schemas.microsoft.com/office/drawing/2014/main" id="{5729F14B-0019-45E3-BB68-97DD1103A683}"/>
               </a:ext>
             </a:extLst>
           </p:cNvPr>
@@ -11112,7 +10870,7 @@
           <p:cNvPr id="4" name="">
             <a:extLst xmlns:a="http://schemas.openxmlformats.org/drawingml/2006/main">
               <a:ext uri="{FF2B5EF4-FFF2-40B4-BE49-F238E27FC236}">
-                <a16:creationId xmlns:a16="http://schemas.microsoft.com/office/drawing/2014/main" id="{054F10EC-3FB3-4FB6-80D4-37C0CE669550}"/>
+                <a16:creationId xmlns:a16="http://schemas.microsoft.com/office/drawing/2014/main" id="{58AD325D-32F4-41D8-9565-2E99B6DD26C3}"/>
               </a:ext>
             </a:extLst>
           </p:cNvPr>
@@ -11143,7 +10901,7 @@
           <p:cNvPr id="5" name="">
             <a:extLst xmlns:a="http://schemas.openxmlformats.org/drawingml/2006/main">
               <a:ext uri="{FF2B5EF4-FFF2-40B4-BE49-F238E27FC236}">
-                <a16:creationId xmlns:a16="http://schemas.microsoft.com/office/drawing/2014/main" id="{C3BD3EB7-0F65-488C-A9B8-412721019B35}"/>
+                <a16:creationId xmlns:a16="http://schemas.microsoft.com/office/drawing/2014/main" id="{AF1EC092-0DEC-4BF5-9829-20FBB183919E}"/>
               </a:ext>
             </a:extLst>
           </p:cNvPr>
@@ -11264,7 +11022,7 @@
           <p:cNvPr id="6" name="">
             <a:extLst xmlns:a="http://schemas.openxmlformats.org/drawingml/2006/main">
               <a:ext uri="{FF2B5EF4-FFF2-40B4-BE49-F238E27FC236}">
-                <a16:creationId xmlns:a16="http://schemas.microsoft.com/office/drawing/2014/main" id="{CC584BD7-87E1-4924-9D46-E50FE86C202C}"/>
+                <a16:creationId xmlns:a16="http://schemas.microsoft.com/office/drawing/2014/main" id="{2882C92A-BF37-42C3-953D-48269DA6C7F2}"/>
               </a:ext>
             </a:extLst>
           </p:cNvPr>
@@ -11385,7 +11143,7 @@
           <p:cNvPr id="7" name="">
             <a:extLst xmlns:a="http://schemas.openxmlformats.org/drawingml/2006/main">
               <a:ext uri="{FF2B5EF4-FFF2-40B4-BE49-F238E27FC236}">
-                <a16:creationId xmlns:a16="http://schemas.microsoft.com/office/drawing/2014/main" id="{43B58C7C-7561-45AB-8338-B759ABDC33AD}"/>
+                <a16:creationId xmlns:a16="http://schemas.microsoft.com/office/drawing/2014/main" id="{A358E861-9F49-460A-BB0A-35A2006347B8}"/>
               </a:ext>
             </a:extLst>
           </p:cNvPr>
@@ -11420,7 +11178,7 @@
           <p:cNvPr id="8" name="">
             <a:extLst xmlns:a="http://schemas.openxmlformats.org/drawingml/2006/main">
               <a:ext uri="{FF2B5EF4-FFF2-40B4-BE49-F238E27FC236}">
-                <a16:creationId xmlns:a16="http://schemas.microsoft.com/office/drawing/2014/main" id="{939E2DFB-6191-48CC-933F-B7BCC0C92E30}"/>
+                <a16:creationId xmlns:a16="http://schemas.microsoft.com/office/drawing/2014/main" id="{12860D68-96C0-4291-B8D5-13EC7D6EFCA6}"/>
               </a:ext>
             </a:extLst>
           </p:cNvPr>
@@ -11541,7 +11299,7 @@
           <p:cNvPr id="9" name="">
             <a:extLst xmlns:a="http://schemas.openxmlformats.org/drawingml/2006/main">
               <a:ext uri="{FF2B5EF4-FFF2-40B4-BE49-F238E27FC236}">
-                <a16:creationId xmlns:a16="http://schemas.microsoft.com/office/drawing/2014/main" id="{023952B5-E744-44BB-BFE5-3533E037D8BC}"/>
+                <a16:creationId xmlns:a16="http://schemas.microsoft.com/office/drawing/2014/main" id="{4EEE39E2-E663-4177-92F6-97839285696F}"/>
               </a:ext>
             </a:extLst>
           </p:cNvPr>
@@ -11576,7 +11334,7 @@
           <p:cNvPr id="10" name="">
             <a:extLst xmlns:a="http://schemas.openxmlformats.org/drawingml/2006/main">
               <a:ext uri="{FF2B5EF4-FFF2-40B4-BE49-F238E27FC236}">
-                <a16:creationId xmlns:a16="http://schemas.microsoft.com/office/drawing/2014/main" id="{76E73712-2F36-4012-A966-A430686BDC7E}"/>
+                <a16:creationId xmlns:a16="http://schemas.microsoft.com/office/drawing/2014/main" id="{0BFC207D-F45F-4D35-B8C1-A4CD8141F2FA}"/>
               </a:ext>
             </a:extLst>
           </p:cNvPr>
@@ -11714,7 +11472,7 @@
           <p:cNvPr id="11" name="">
             <a:extLst xmlns:a="http://schemas.openxmlformats.org/drawingml/2006/main">
               <a:ext uri="{FF2B5EF4-FFF2-40B4-BE49-F238E27FC236}">
-                <a16:creationId xmlns:a16="http://schemas.microsoft.com/office/drawing/2014/main" id="{B65F97DB-6E18-4CB6-A691-D535E13E2664}"/>
+                <a16:creationId xmlns:a16="http://schemas.microsoft.com/office/drawing/2014/main" id="{2303DB67-B7D3-4F1C-AC25-56E78B8852CD}"/>
               </a:ext>
             </a:extLst>
           </p:cNvPr>
@@ -11749,7 +11507,7 @@
           <p:cNvPr id="12" name="">
             <a:extLst xmlns:a="http://schemas.openxmlformats.org/drawingml/2006/main">
               <a:ext uri="{FF2B5EF4-FFF2-40B4-BE49-F238E27FC236}">
-                <a16:creationId xmlns:a16="http://schemas.microsoft.com/office/drawing/2014/main" id="{DA344B6C-6EF3-4163-B752-168BCE3A8E3B}"/>
+                <a16:creationId xmlns:a16="http://schemas.microsoft.com/office/drawing/2014/main" id="{AA70FF8E-7C1A-481D-BEBA-1E24B95E6510}"/>
               </a:ext>
             </a:extLst>
           </p:cNvPr>
@@ -11887,7 +11645,7 @@
           <p:cNvPr id="13" name="">
             <a:extLst xmlns:a="http://schemas.openxmlformats.org/drawingml/2006/main">
               <a:ext uri="{FF2B5EF4-FFF2-40B4-BE49-F238E27FC236}">
-                <a16:creationId xmlns:a16="http://schemas.microsoft.com/office/drawing/2014/main" id="{151B8848-2602-46A2-9571-616B3A5384B6}"/>
+                <a16:creationId xmlns:a16="http://schemas.microsoft.com/office/drawing/2014/main" id="{02F91A0D-89A8-422B-9DA1-4F11B564CB64}"/>
               </a:ext>
             </a:extLst>
           </p:cNvPr>
@@ -11922,7 +11680,7 @@
           <p:cNvPr id="14" name="">
             <a:extLst xmlns:a="http://schemas.openxmlformats.org/drawingml/2006/main">
               <a:ext uri="{FF2B5EF4-FFF2-40B4-BE49-F238E27FC236}">
-                <a16:creationId xmlns:a16="http://schemas.microsoft.com/office/drawing/2014/main" id="{BC0C8AFA-0C49-4A14-8BD2-1317E21E629F}"/>
+                <a16:creationId xmlns:a16="http://schemas.microsoft.com/office/drawing/2014/main" id="{D5FA7454-C68F-4461-B362-96AF8E0A1FB1}"/>
               </a:ext>
             </a:extLst>
           </p:cNvPr>
@@ -12043,7 +11801,7 @@
           <p:cNvPr id="15" name="">
             <a:extLst xmlns:a="http://schemas.openxmlformats.org/drawingml/2006/main">
               <a:ext uri="{FF2B5EF4-FFF2-40B4-BE49-F238E27FC236}">
-                <a16:creationId xmlns:a16="http://schemas.microsoft.com/office/drawing/2014/main" id="{3B8F0648-BF57-4698-A19B-9EE387020E20}"/>
+                <a16:creationId xmlns:a16="http://schemas.microsoft.com/office/drawing/2014/main" id="{02C1729A-F0B0-468C-A8E3-56272462D80A}"/>
               </a:ext>
             </a:extLst>
           </p:cNvPr>
@@ -12078,7 +11836,7 @@
           <p:cNvPr id="16" name="">
             <a:extLst xmlns:a="http://schemas.openxmlformats.org/drawingml/2006/main">
               <a:ext uri="{FF2B5EF4-FFF2-40B4-BE49-F238E27FC236}">
-                <a16:creationId xmlns:a16="http://schemas.microsoft.com/office/drawing/2014/main" id="{6D699452-6517-4066-B618-29937B5CB565}"/>
+                <a16:creationId xmlns:a16="http://schemas.microsoft.com/office/drawing/2014/main" id="{53B3B78B-8B89-4360-A8ED-CEB9F9ECAE3C}"/>
               </a:ext>
             </a:extLst>
           </p:cNvPr>
@@ -12199,7 +11957,7 @@
           <p:cNvPr id="17" name="">
             <a:extLst xmlns:a="http://schemas.openxmlformats.org/drawingml/2006/main">
               <a:ext uri="{FF2B5EF4-FFF2-40B4-BE49-F238E27FC236}">
-                <a16:creationId xmlns:a16="http://schemas.microsoft.com/office/drawing/2014/main" id="{F63CC00C-0376-45CD-A4BD-0C416BBE6096}"/>
+                <a16:creationId xmlns:a16="http://schemas.microsoft.com/office/drawing/2014/main" id="{3040A9FE-BCD5-4092-B153-B99BB5123D93}"/>
               </a:ext>
             </a:extLst>
           </p:cNvPr>
@@ -12234,7 +11992,7 @@
           <p:cNvPr id="18" name="">
             <a:extLst xmlns:a="http://schemas.openxmlformats.org/drawingml/2006/main">
               <a:ext uri="{FF2B5EF4-FFF2-40B4-BE49-F238E27FC236}">
-                <a16:creationId xmlns:a16="http://schemas.microsoft.com/office/drawing/2014/main" id="{3DD3E909-F9F4-4F76-8E56-88BBA9FDB61B}"/>
+                <a16:creationId xmlns:a16="http://schemas.microsoft.com/office/drawing/2014/main" id="{4532A856-6D96-4D97-A7E4-5D2935332BBF}"/>
               </a:ext>
             </a:extLst>
           </p:cNvPr>
@@ -12372,7 +12130,7 @@
           <p:cNvPr id="19" name="">
             <a:extLst xmlns:a="http://schemas.openxmlformats.org/drawingml/2006/main">
               <a:ext uri="{FF2B5EF4-FFF2-40B4-BE49-F238E27FC236}">
-                <a16:creationId xmlns:a16="http://schemas.microsoft.com/office/drawing/2014/main" id="{B27F0F6B-C91E-4322-B643-A050BDEB3C69}"/>
+                <a16:creationId xmlns:a16="http://schemas.microsoft.com/office/drawing/2014/main" id="{4A767B9C-0F8F-4F4C-8A76-68C979D7F2E2}"/>
               </a:ext>
             </a:extLst>
           </p:cNvPr>
@@ -12407,7 +12165,7 @@
           <p:cNvPr id="20" name="">
             <a:extLst xmlns:a="http://schemas.openxmlformats.org/drawingml/2006/main">
               <a:ext uri="{FF2B5EF4-FFF2-40B4-BE49-F238E27FC236}">
-                <a16:creationId xmlns:a16="http://schemas.microsoft.com/office/drawing/2014/main" id="{F558DD07-A7DF-41B5-A077-2BBF7D877EA0}"/>
+                <a16:creationId xmlns:a16="http://schemas.microsoft.com/office/drawing/2014/main" id="{101CB224-DFEE-4D07-B951-D6B2A887B25C}"/>
               </a:ext>
             </a:extLst>
           </p:cNvPr>
@@ -12545,7 +12303,7 @@
           <p:cNvPr id="21" name="">
             <a:extLst xmlns:a="http://schemas.openxmlformats.org/drawingml/2006/main">
               <a:ext uri="{FF2B5EF4-FFF2-40B4-BE49-F238E27FC236}">
-                <a16:creationId xmlns:a16="http://schemas.microsoft.com/office/drawing/2014/main" id="{F2309B9A-B68D-463C-BCF6-1B6215D4A1D9}"/>
+                <a16:creationId xmlns:a16="http://schemas.microsoft.com/office/drawing/2014/main" id="{230B8847-1DE1-4021-8B0B-80D5EFE1DED6}"/>
               </a:ext>
             </a:extLst>
           </p:cNvPr>
@@ -12580,7 +12338,7 @@
           <p:cNvPr id="22" name="">
             <a:extLst xmlns:a="http://schemas.openxmlformats.org/drawingml/2006/main">
               <a:ext uri="{FF2B5EF4-FFF2-40B4-BE49-F238E27FC236}">
-                <a16:creationId xmlns:a16="http://schemas.microsoft.com/office/drawing/2014/main" id="{4BDD43DD-D064-4910-823B-06BFA6988261}"/>
+                <a16:creationId xmlns:a16="http://schemas.microsoft.com/office/drawing/2014/main" id="{2F3BA91E-2F35-43C1-93C4-FE7FDAF3648B}"/>
               </a:ext>
             </a:extLst>
           </p:cNvPr>
@@ -12718,7 +12476,7 @@
           <p:cNvPr id="23" name="">
             <a:extLst xmlns:a="http://schemas.openxmlformats.org/drawingml/2006/main">
               <a:ext uri="{FF2B5EF4-FFF2-40B4-BE49-F238E27FC236}">
-                <a16:creationId xmlns:a16="http://schemas.microsoft.com/office/drawing/2014/main" id="{1C2126D9-C56A-473D-B061-19C475647431}"/>
+                <a16:creationId xmlns:a16="http://schemas.microsoft.com/office/drawing/2014/main" id="{1AC8F0CC-CD0D-4B3D-94DF-A3F88128835D}"/>
               </a:ext>
             </a:extLst>
           </p:cNvPr>
@@ -12839,7 +12597,7 @@
           <p:cNvPr id="24" name="">
             <a:extLst xmlns:a="http://schemas.openxmlformats.org/drawingml/2006/main">
               <a:ext uri="{FF2B5EF4-FFF2-40B4-BE49-F238E27FC236}">
-                <a16:creationId xmlns:a16="http://schemas.microsoft.com/office/drawing/2014/main" id="{7B26FBFD-181E-449E-9EE1-6CA516994677}"/>
+                <a16:creationId xmlns:a16="http://schemas.microsoft.com/office/drawing/2014/main" id="{02FB0FED-7454-40D3-9253-E38FC5EF0632}"/>
               </a:ext>
             </a:extLst>
           </p:cNvPr>
@@ -12870,7 +12628,7 @@
           <p:cNvPr id="25" name="">
             <a:extLst xmlns:a="http://schemas.openxmlformats.org/drawingml/2006/main">
               <a:ext uri="{FF2B5EF4-FFF2-40B4-BE49-F238E27FC236}">
-                <a16:creationId xmlns:a16="http://schemas.microsoft.com/office/drawing/2014/main" id="{6D2FBE66-0F26-49E1-87D6-24535B4DE916}"/>
+                <a16:creationId xmlns:a16="http://schemas.microsoft.com/office/drawing/2014/main" id="{8AFB7D3B-BA92-48BE-91D6-3B9F90D430A0}"/>
               </a:ext>
             </a:extLst>
           </p:cNvPr>
@@ -12989,7 +12747,7 @@
     </p:spTree>
     <p:extLst>
       <p:ext uri="{BB962C8B-B14F-4D97-AF65-F5344CB8AC3E}">
-        <p14:creationId xmlns:p14="http://schemas.microsoft.com/office/powerpoint/2010/main" val="456803091"/>
+        <p14:creationId xmlns:p14="http://schemas.microsoft.com/office/powerpoint/2010/main" val="810894314"/>
       </p:ext>
     </p:extLst>
   </p:cSld>
@@ -13020,7 +12778,7 @@
           <p:cNvPr id="31" name="">
             <a:extLst xmlns:a="http://schemas.openxmlformats.org/drawingml/2006/main">
               <a:ext uri="{FF2B5EF4-FFF2-40B4-BE49-F238E27FC236}">
-                <a16:creationId xmlns:a16="http://schemas.microsoft.com/office/drawing/2014/main" id="{7CA7F17A-FC5C-4D75-B39B-1E4A6D674F24}"/>
+                <a16:creationId xmlns:a16="http://schemas.microsoft.com/office/drawing/2014/main" id="{82029C68-0766-4E79-8B38-DFE23B98BE39}"/>
               </a:ext>
             </a:extLst>
           </p:cNvPr>
@@ -13051,7 +12809,7 @@
           <p:cNvPr id="2" name="">
             <a:extLst xmlns:a="http://schemas.openxmlformats.org/drawingml/2006/main">
               <a:ext uri="{FF2B5EF4-FFF2-40B4-BE49-F238E27FC236}">
-                <a16:creationId xmlns:a16="http://schemas.microsoft.com/office/drawing/2014/main" id="{DC995F08-E3FE-4EB6-B060-BD45DF9545B2}"/>
+                <a16:creationId xmlns:a16="http://schemas.microsoft.com/office/drawing/2014/main" id="{2CCE4E67-4774-477F-A3E6-E7BFA0BDE5E7}"/>
               </a:ext>
             </a:extLst>
           </p:cNvPr>
@@ -13172,7 +12930,7 @@
           <p:cNvPr id="3" name="">
             <a:extLst xmlns:a="http://schemas.openxmlformats.org/drawingml/2006/main">
               <a:ext uri="{FF2B5EF4-FFF2-40B4-BE49-F238E27FC236}">
-                <a16:creationId xmlns:a16="http://schemas.microsoft.com/office/drawing/2014/main" id="{EA591155-9EA7-42EE-BBCF-4D429489E623}"/>
+                <a16:creationId xmlns:a16="http://schemas.microsoft.com/office/drawing/2014/main" id="{F81A5667-10AE-49EB-92C4-D8BBF8F70CA4}"/>
               </a:ext>
             </a:extLst>
           </p:cNvPr>
@@ -13293,7 +13051,7 @@
           <p:cNvPr id="4" name="">
             <a:extLst xmlns:a="http://schemas.openxmlformats.org/drawingml/2006/main">
               <a:ext uri="{FF2B5EF4-FFF2-40B4-BE49-F238E27FC236}">
-                <a16:creationId xmlns:a16="http://schemas.microsoft.com/office/drawing/2014/main" id="{72947057-E6C1-4BC1-93FD-7A48B0EAC58E}"/>
+                <a16:creationId xmlns:a16="http://schemas.microsoft.com/office/drawing/2014/main" id="{97BCC7F4-2CBF-4FEE-8781-94CBD4BCCCD7}"/>
               </a:ext>
             </a:extLst>
           </p:cNvPr>
@@ -13324,7 +13082,7 @@
           <p:cNvPr id="5" name="">
             <a:extLst xmlns:a="http://schemas.openxmlformats.org/drawingml/2006/main">
               <a:ext uri="{FF2B5EF4-FFF2-40B4-BE49-F238E27FC236}">
-                <a16:creationId xmlns:a16="http://schemas.microsoft.com/office/drawing/2014/main" id="{D8CF8D8B-6EA3-4EAC-B264-B9D819E0AC8F}"/>
+                <a16:creationId xmlns:a16="http://schemas.microsoft.com/office/drawing/2014/main" id="{5604D3CA-6D7A-4014-B3DA-85FBFF8D6ADC}"/>
               </a:ext>
             </a:extLst>
           </p:cNvPr>
@@ -13445,7 +13203,7 @@
           <p:cNvPr id="6" name="">
             <a:extLst xmlns:a="http://schemas.openxmlformats.org/drawingml/2006/main">
               <a:ext uri="{FF2B5EF4-FFF2-40B4-BE49-F238E27FC236}">
-                <a16:creationId xmlns:a16="http://schemas.microsoft.com/office/drawing/2014/main" id="{7C25E29D-C7B6-4975-8072-23E8361631A1}"/>
+                <a16:creationId xmlns:a16="http://schemas.microsoft.com/office/drawing/2014/main" id="{0F85E726-6987-4BD2-951E-26B6E90AEF94}"/>
               </a:ext>
             </a:extLst>
           </p:cNvPr>
@@ -13566,7 +13324,7 @@
           <p:cNvPr id="7" name="">
             <a:extLst xmlns:a="http://schemas.openxmlformats.org/drawingml/2006/main">
               <a:ext uri="{FF2B5EF4-FFF2-40B4-BE49-F238E27FC236}">
-                <a16:creationId xmlns:a16="http://schemas.microsoft.com/office/drawing/2014/main" id="{4BF7558B-EF9A-4368-9602-DDBE0296B75B}"/>
+                <a16:creationId xmlns:a16="http://schemas.microsoft.com/office/drawing/2014/main" id="{66385C12-448A-4792-A5B7-2DF7FA9FD249}"/>
               </a:ext>
             </a:extLst>
           </p:cNvPr>
@@ -13687,7 +13445,7 @@
           <p:cNvPr id="8" name="">
             <a:extLst xmlns:a="http://schemas.openxmlformats.org/drawingml/2006/main">
               <a:ext uri="{FF2B5EF4-FFF2-40B4-BE49-F238E27FC236}">
-                <a16:creationId xmlns:a16="http://schemas.microsoft.com/office/drawing/2014/main" id="{CD277D8B-2F7F-462A-A72D-990A2DEC6304}"/>
+                <a16:creationId xmlns:a16="http://schemas.microsoft.com/office/drawing/2014/main" id="{2E648D3E-6396-4854-A617-2A390A5FF94B}"/>
               </a:ext>
             </a:extLst>
           </p:cNvPr>
@@ -13808,7 +13566,7 @@
           <p:cNvPr id="9" name="">
             <a:extLst xmlns:a="http://schemas.openxmlformats.org/drawingml/2006/main">
               <a:ext uri="{FF2B5EF4-FFF2-40B4-BE49-F238E27FC236}">
-                <a16:creationId xmlns:a16="http://schemas.microsoft.com/office/drawing/2014/main" id="{D9F9B330-60AA-49D1-ADAF-5424156531F9}"/>
+                <a16:creationId xmlns:a16="http://schemas.microsoft.com/office/drawing/2014/main" id="{2531EEAF-802F-4F36-BC92-A679170F6ED9}"/>
               </a:ext>
             </a:extLst>
           </p:cNvPr>
@@ -13929,7 +13687,7 @@
           <p:cNvPr id="10" name="">
             <a:extLst xmlns:a="http://schemas.openxmlformats.org/drawingml/2006/main">
               <a:ext uri="{FF2B5EF4-FFF2-40B4-BE49-F238E27FC236}">
-                <a16:creationId xmlns:a16="http://schemas.microsoft.com/office/drawing/2014/main" id="{7919CB25-51BD-493D-95E8-FEC98CF01256}"/>
+                <a16:creationId xmlns:a16="http://schemas.microsoft.com/office/drawing/2014/main" id="{C7B55A2D-4CFB-4CA4-9DB8-DF8F93FB6607}"/>
               </a:ext>
             </a:extLst>
           </p:cNvPr>
@@ -13960,7 +13718,7 @@
           <p:cNvPr id="11" name="">
             <a:extLst xmlns:a="http://schemas.openxmlformats.org/drawingml/2006/main">
               <a:ext uri="{FF2B5EF4-FFF2-40B4-BE49-F238E27FC236}">
-                <a16:creationId xmlns:a16="http://schemas.microsoft.com/office/drawing/2014/main" id="{9734DEF7-C957-42FC-81B2-4BC8B2BC4C69}"/>
+                <a16:creationId xmlns:a16="http://schemas.microsoft.com/office/drawing/2014/main" id="{2BEA1B4B-0344-4FF0-9DC3-DCB09E5F6E7B}"/>
               </a:ext>
             </a:extLst>
           </p:cNvPr>
@@ -14081,7 +13839,7 @@
           <p:cNvPr id="12" name="">
             <a:extLst xmlns:a="http://schemas.openxmlformats.org/drawingml/2006/main">
               <a:ext uri="{FF2B5EF4-FFF2-40B4-BE49-F238E27FC236}">
-                <a16:creationId xmlns:a16="http://schemas.microsoft.com/office/drawing/2014/main" id="{C45D0764-4EAC-4E03-8113-931B863D6084}"/>
+                <a16:creationId xmlns:a16="http://schemas.microsoft.com/office/drawing/2014/main" id="{D4C2653D-6FDE-420E-9897-2C3E6FF5A5C4}"/>
               </a:ext>
             </a:extLst>
           </p:cNvPr>
@@ -14202,7 +13960,7 @@
           <p:cNvPr id="13" name="">
             <a:extLst xmlns:a="http://schemas.openxmlformats.org/drawingml/2006/main">
               <a:ext uri="{FF2B5EF4-FFF2-40B4-BE49-F238E27FC236}">
-                <a16:creationId xmlns:a16="http://schemas.microsoft.com/office/drawing/2014/main" id="{A0558E8D-F358-4D1B-8741-D4832CD2BE90}"/>
+                <a16:creationId xmlns:a16="http://schemas.microsoft.com/office/drawing/2014/main" id="{C0E9805D-1BE0-4B94-ADF6-1B3ABBABB0E5}"/>
               </a:ext>
             </a:extLst>
           </p:cNvPr>
@@ -14323,7 +14081,7 @@
           <p:cNvPr id="14" name="">
             <a:extLst xmlns:a="http://schemas.openxmlformats.org/drawingml/2006/main">
               <a:ext uri="{FF2B5EF4-FFF2-40B4-BE49-F238E27FC236}">
-                <a16:creationId xmlns:a16="http://schemas.microsoft.com/office/drawing/2014/main" id="{58DF9674-16E1-42F2-A5DA-0FF93BE00389}"/>
+                <a16:creationId xmlns:a16="http://schemas.microsoft.com/office/drawing/2014/main" id="{96EC9251-F0CA-43F2-9B34-452A933140CE}"/>
               </a:ext>
             </a:extLst>
           </p:cNvPr>
@@ -14354,7 +14112,7 @@
           <p:cNvPr id="15" name="">
             <a:extLst xmlns:a="http://schemas.openxmlformats.org/drawingml/2006/main">
               <a:ext uri="{FF2B5EF4-FFF2-40B4-BE49-F238E27FC236}">
-                <a16:creationId xmlns:a16="http://schemas.microsoft.com/office/drawing/2014/main" id="{DFEF8483-823C-443E-8930-E8D12A708DA2}"/>
+                <a16:creationId xmlns:a16="http://schemas.microsoft.com/office/drawing/2014/main" id="{3BACB4FB-22D6-4FFD-A3E6-61931C0D41DD}"/>
               </a:ext>
             </a:extLst>
           </p:cNvPr>
@@ -14475,7 +14233,7 @@
           <p:cNvPr id="16" name="">
             <a:extLst xmlns:a="http://schemas.openxmlformats.org/drawingml/2006/main">
               <a:ext uri="{FF2B5EF4-FFF2-40B4-BE49-F238E27FC236}">
-                <a16:creationId xmlns:a16="http://schemas.microsoft.com/office/drawing/2014/main" id="{C86469B3-DED6-47D1-A960-75E576C36223}"/>
+                <a16:creationId xmlns:a16="http://schemas.microsoft.com/office/drawing/2014/main" id="{652501E5-DB6D-4365-B70D-5F34179119FE}"/>
               </a:ext>
             </a:extLst>
           </p:cNvPr>
@@ -14596,7 +14354,7 @@
           <p:cNvPr id="17" name="">
             <a:extLst xmlns:a="http://schemas.openxmlformats.org/drawingml/2006/main">
               <a:ext uri="{FF2B5EF4-FFF2-40B4-BE49-F238E27FC236}">
-                <a16:creationId xmlns:a16="http://schemas.microsoft.com/office/drawing/2014/main" id="{6CF1641E-3344-4123-89EE-5A77C031E40C}"/>
+                <a16:creationId xmlns:a16="http://schemas.microsoft.com/office/drawing/2014/main" id="{D848401F-8D1A-4516-BAA6-1B4729C2A9E8}"/>
               </a:ext>
             </a:extLst>
           </p:cNvPr>
@@ -14717,7 +14475,7 @@
           <p:cNvPr id="18" name="">
             <a:extLst xmlns:a="http://schemas.openxmlformats.org/drawingml/2006/main">
               <a:ext uri="{FF2B5EF4-FFF2-40B4-BE49-F238E27FC236}">
-                <a16:creationId xmlns:a16="http://schemas.microsoft.com/office/drawing/2014/main" id="{67043F0F-26B5-4DFE-B1FE-7358871B53A2}"/>
+                <a16:creationId xmlns:a16="http://schemas.microsoft.com/office/drawing/2014/main" id="{CDDB3F6E-365A-4129-8FB0-D9F625CCACC4}"/>
               </a:ext>
             </a:extLst>
           </p:cNvPr>
@@ -14748,7 +14506,7 @@
           <p:cNvPr id="19" name="">
             <a:extLst xmlns:a="http://schemas.openxmlformats.org/drawingml/2006/main">
               <a:ext uri="{FF2B5EF4-FFF2-40B4-BE49-F238E27FC236}">
-                <a16:creationId xmlns:a16="http://schemas.microsoft.com/office/drawing/2014/main" id="{57C80448-ADB9-47D1-A431-A1A9B5B30CC4}"/>
+                <a16:creationId xmlns:a16="http://schemas.microsoft.com/office/drawing/2014/main" id="{21FC7FCC-8F4B-4A74-BD8D-43F1DF20E0FE}"/>
               </a:ext>
             </a:extLst>
           </p:cNvPr>
@@ -14869,7 +14627,7 @@
           <p:cNvPr id="20" name="">
             <a:extLst xmlns:a="http://schemas.openxmlformats.org/drawingml/2006/main">
               <a:ext uri="{FF2B5EF4-FFF2-40B4-BE49-F238E27FC236}">
-                <a16:creationId xmlns:a16="http://schemas.microsoft.com/office/drawing/2014/main" id="{B5CB6D92-3C7C-468E-AB48-500137D668D3}"/>
+                <a16:creationId xmlns:a16="http://schemas.microsoft.com/office/drawing/2014/main" id="{1CD1693C-A3E1-4441-82AF-27DB54B35E6C}"/>
               </a:ext>
             </a:extLst>
           </p:cNvPr>
@@ -14990,7 +14748,7 @@
           <p:cNvPr id="21" name="">
             <a:extLst xmlns:a="http://schemas.openxmlformats.org/drawingml/2006/main">
               <a:ext uri="{FF2B5EF4-FFF2-40B4-BE49-F238E27FC236}">
-                <a16:creationId xmlns:a16="http://schemas.microsoft.com/office/drawing/2014/main" id="{A9A4EBCD-8646-4617-AEFE-5F145395916A}"/>
+                <a16:creationId xmlns:a16="http://schemas.microsoft.com/office/drawing/2014/main" id="{4178475D-194C-4C4A-BE01-BE413A6D025C}"/>
               </a:ext>
             </a:extLst>
           </p:cNvPr>
@@ -15111,7 +14869,7 @@
           <p:cNvPr id="22" name="">
             <a:extLst xmlns:a="http://schemas.openxmlformats.org/drawingml/2006/main">
               <a:ext uri="{FF2B5EF4-FFF2-40B4-BE49-F238E27FC236}">
-                <a16:creationId xmlns:a16="http://schemas.microsoft.com/office/drawing/2014/main" id="{56451EB9-68AE-412B-8A52-577B529BFEC7}"/>
+                <a16:creationId xmlns:a16="http://schemas.microsoft.com/office/drawing/2014/main" id="{9AB1FCBD-EAC4-4927-A5FD-1779235AD85F}"/>
               </a:ext>
             </a:extLst>
           </p:cNvPr>
@@ -15142,7 +14900,7 @@
           <p:cNvPr id="23" name="">
             <a:extLst xmlns:a="http://schemas.openxmlformats.org/drawingml/2006/main">
               <a:ext uri="{FF2B5EF4-FFF2-40B4-BE49-F238E27FC236}">
-                <a16:creationId xmlns:a16="http://schemas.microsoft.com/office/drawing/2014/main" id="{F6A1F18B-D635-4152-9BB5-99F09C2BF149}"/>
+                <a16:creationId xmlns:a16="http://schemas.microsoft.com/office/drawing/2014/main" id="{ECE993C7-FEDB-4605-9302-CEF3C9601391}"/>
               </a:ext>
             </a:extLst>
           </p:cNvPr>
@@ -15263,7 +15021,7 @@
           <p:cNvPr id="24" name="">
             <a:extLst xmlns:a="http://schemas.openxmlformats.org/drawingml/2006/main">
               <a:ext uri="{FF2B5EF4-FFF2-40B4-BE49-F238E27FC236}">
-                <a16:creationId xmlns:a16="http://schemas.microsoft.com/office/drawing/2014/main" id="{50A76A20-3104-4C89-8E4E-9951AAEE74F5}"/>
+                <a16:creationId xmlns:a16="http://schemas.microsoft.com/office/drawing/2014/main" id="{1639C105-D5C1-4A84-9E09-0DD5B1F0EAAF}"/>
               </a:ext>
             </a:extLst>
           </p:cNvPr>
@@ -15384,7 +15142,7 @@
           <p:cNvPr id="25" name="">
             <a:extLst xmlns:a="http://schemas.openxmlformats.org/drawingml/2006/main">
               <a:ext uri="{FF2B5EF4-FFF2-40B4-BE49-F238E27FC236}">
-                <a16:creationId xmlns:a16="http://schemas.microsoft.com/office/drawing/2014/main" id="{69CE70EF-90C3-402F-B05C-47F0E677FA86}"/>
+                <a16:creationId xmlns:a16="http://schemas.microsoft.com/office/drawing/2014/main" id="{F69C2CF1-74E8-4BAC-9AD0-3922FF5CAA8C}"/>
               </a:ext>
             </a:extLst>
           </p:cNvPr>
@@ -15505,7 +15263,7 @@
           <p:cNvPr id="26" name="">
             <a:extLst xmlns:a="http://schemas.openxmlformats.org/drawingml/2006/main">
               <a:ext uri="{FF2B5EF4-FFF2-40B4-BE49-F238E27FC236}">
-                <a16:creationId xmlns:a16="http://schemas.microsoft.com/office/drawing/2014/main" id="{590F21F9-C0E8-4969-9233-DD7F55F51077}"/>
+                <a16:creationId xmlns:a16="http://schemas.microsoft.com/office/drawing/2014/main" id="{08974766-60CB-4F88-9AB1-DA2CAA38D22F}"/>
               </a:ext>
             </a:extLst>
           </p:cNvPr>
@@ -15536,7 +15294,7 @@
           <p:cNvPr id="27" name="">
             <a:extLst xmlns:a="http://schemas.openxmlformats.org/drawingml/2006/main">
               <a:ext uri="{FF2B5EF4-FFF2-40B4-BE49-F238E27FC236}">
-                <a16:creationId xmlns:a16="http://schemas.microsoft.com/office/drawing/2014/main" id="{790EF3C4-81EB-4842-A902-EB0DD8C4ABFF}"/>
+                <a16:creationId xmlns:a16="http://schemas.microsoft.com/office/drawing/2014/main" id="{1D017E1A-4884-4162-B58C-D24D6527F93A}"/>
               </a:ext>
             </a:extLst>
           </p:cNvPr>
@@ -15657,7 +15415,7 @@
           <p:cNvPr id="28" name="">
             <a:extLst xmlns:a="http://schemas.openxmlformats.org/drawingml/2006/main">
               <a:ext uri="{FF2B5EF4-FFF2-40B4-BE49-F238E27FC236}">
-                <a16:creationId xmlns:a16="http://schemas.microsoft.com/office/drawing/2014/main" id="{0CD2E972-F2D5-4966-BFBE-6DC115C5C8BC}"/>
+                <a16:creationId xmlns:a16="http://schemas.microsoft.com/office/drawing/2014/main" id="{706259A7-DCE5-481A-A6A1-ED8896470A2D}"/>
               </a:ext>
             </a:extLst>
           </p:cNvPr>
@@ -15778,7 +15536,7 @@
           <p:cNvPr id="29" name="">
             <a:extLst xmlns:a="http://schemas.openxmlformats.org/drawingml/2006/main">
               <a:ext uri="{FF2B5EF4-FFF2-40B4-BE49-F238E27FC236}">
-                <a16:creationId xmlns:a16="http://schemas.microsoft.com/office/drawing/2014/main" id="{610C966B-096A-4763-B9BC-662DF8D5CAB9}"/>
+                <a16:creationId xmlns:a16="http://schemas.microsoft.com/office/drawing/2014/main" id="{8DEB6B06-F105-49BF-91DD-45E5206A96C9}"/>
               </a:ext>
             </a:extLst>
           </p:cNvPr>
@@ -15899,7 +15657,7 @@
           <p:cNvPr id="30" name="">
             <a:extLst xmlns:a="http://schemas.openxmlformats.org/drawingml/2006/main">
               <a:ext uri="{FF2B5EF4-FFF2-40B4-BE49-F238E27FC236}">
-                <a16:creationId xmlns:a16="http://schemas.microsoft.com/office/drawing/2014/main" id="{CA14735D-090A-4AAF-BC1F-7083B670BE45}"/>
+                <a16:creationId xmlns:a16="http://schemas.microsoft.com/office/drawing/2014/main" id="{979A05B9-B559-4283-92BA-ABD650958184}"/>
               </a:ext>
             </a:extLst>
           </p:cNvPr>
@@ -16018,7 +15776,7 @@
     </p:spTree>
     <p:extLst>
       <p:ext uri="{BB962C8B-B14F-4D97-AF65-F5344CB8AC3E}">
-        <p14:creationId xmlns:p14="http://schemas.microsoft.com/office/powerpoint/2010/main" val="952656225"/>
+        <p14:creationId xmlns:p14="http://schemas.microsoft.com/office/powerpoint/2010/main" val="1623423001"/>
       </p:ext>
     </p:extLst>
   </p:cSld>
@@ -16049,7 +15807,7 @@
           <p:cNvPr id="24" name="">
             <a:extLst xmlns:a="http://schemas.openxmlformats.org/drawingml/2006/main">
               <a:ext uri="{FF2B5EF4-FFF2-40B4-BE49-F238E27FC236}">
-                <a16:creationId xmlns:a16="http://schemas.microsoft.com/office/drawing/2014/main" id="{D3FBE157-B70B-4485-B2F8-C9BF34A65D35}"/>
+                <a16:creationId xmlns:a16="http://schemas.microsoft.com/office/drawing/2014/main" id="{D68A812E-2AFC-40CD-9727-303AC21D16B6}"/>
               </a:ext>
             </a:extLst>
           </p:cNvPr>
@@ -16080,7 +15838,7 @@
           <p:cNvPr id="2" name="">
             <a:extLst xmlns:a="http://schemas.openxmlformats.org/drawingml/2006/main">
               <a:ext uri="{FF2B5EF4-FFF2-40B4-BE49-F238E27FC236}">
-                <a16:creationId xmlns:a16="http://schemas.microsoft.com/office/drawing/2014/main" id="{DFDF5C1E-AC37-4A75-9526-1E5962FCF6A8}"/>
+                <a16:creationId xmlns:a16="http://schemas.microsoft.com/office/drawing/2014/main" id="{B62AF4C0-0A3A-406C-B77A-060CD8309215}"/>
               </a:ext>
             </a:extLst>
           </p:cNvPr>
@@ -16201,7 +15959,7 @@
           <p:cNvPr id="3" name="">
             <a:extLst xmlns:a="http://schemas.openxmlformats.org/drawingml/2006/main">
               <a:ext uri="{FF2B5EF4-FFF2-40B4-BE49-F238E27FC236}">
-                <a16:creationId xmlns:a16="http://schemas.microsoft.com/office/drawing/2014/main" id="{A3D0C20D-CB4E-4174-9040-C2ABD5D5F412}"/>
+                <a16:creationId xmlns:a16="http://schemas.microsoft.com/office/drawing/2014/main" id="{8BC30AF1-C2E0-40BF-A9F4-8086AE26BB6B}"/>
               </a:ext>
             </a:extLst>
           </p:cNvPr>
@@ -16322,7 +16080,7 @@
           <p:cNvPr id="4" name="">
             <a:extLst xmlns:a="http://schemas.openxmlformats.org/drawingml/2006/main">
               <a:ext uri="{FF2B5EF4-FFF2-40B4-BE49-F238E27FC236}">
-                <a16:creationId xmlns:a16="http://schemas.microsoft.com/office/drawing/2014/main" id="{7455284A-C27B-463B-8DB7-64DECD1CCABC}"/>
+                <a16:creationId xmlns:a16="http://schemas.microsoft.com/office/drawing/2014/main" id="{E79E088B-92D6-458A-BFA6-4BA7C03EC91D}"/>
               </a:ext>
             </a:extLst>
           </p:cNvPr>
@@ -16353,7 +16111,7 @@
           <p:cNvPr id="5" name="">
             <a:extLst xmlns:a="http://schemas.openxmlformats.org/drawingml/2006/main">
               <a:ext uri="{FF2B5EF4-FFF2-40B4-BE49-F238E27FC236}">
-                <a16:creationId xmlns:a16="http://schemas.microsoft.com/office/drawing/2014/main" id="{720CB64A-D477-48B7-BE0F-24F58CF82C5F}"/>
+                <a16:creationId xmlns:a16="http://schemas.microsoft.com/office/drawing/2014/main" id="{F3520F2A-645F-4C0B-863E-790ADBE20E5F}"/>
               </a:ext>
             </a:extLst>
           </p:cNvPr>
@@ -16474,7 +16232,7 @@
           <p:cNvPr id="6" name="">
             <a:extLst xmlns:a="http://schemas.openxmlformats.org/drawingml/2006/main">
               <a:ext uri="{FF2B5EF4-FFF2-40B4-BE49-F238E27FC236}">
-                <a16:creationId xmlns:a16="http://schemas.microsoft.com/office/drawing/2014/main" id="{1BF01576-33B3-475E-A0A4-A368726E00F6}"/>
+                <a16:creationId xmlns:a16="http://schemas.microsoft.com/office/drawing/2014/main" id="{AF689D02-0FDE-462C-8BFC-483E9B563888}"/>
               </a:ext>
             </a:extLst>
           </p:cNvPr>
@@ -16595,7 +16353,7 @@
           <p:cNvPr id="7" name="">
             <a:extLst xmlns:a="http://schemas.openxmlformats.org/drawingml/2006/main">
               <a:ext uri="{FF2B5EF4-FFF2-40B4-BE49-F238E27FC236}">
-                <a16:creationId xmlns:a16="http://schemas.microsoft.com/office/drawing/2014/main" id="{B5E7E127-F80A-4BEB-A217-E39780906BC5}"/>
+                <a16:creationId xmlns:a16="http://schemas.microsoft.com/office/drawing/2014/main" id="{C34698BB-4607-4A84-889C-BB9FE52ED812}"/>
               </a:ext>
             </a:extLst>
           </p:cNvPr>
@@ -16716,7 +16474,7 @@
           <p:cNvPr id="8" name="">
             <a:extLst xmlns:a="http://schemas.openxmlformats.org/drawingml/2006/main">
               <a:ext uri="{FF2B5EF4-FFF2-40B4-BE49-F238E27FC236}">
-                <a16:creationId xmlns:a16="http://schemas.microsoft.com/office/drawing/2014/main" id="{794867EC-034A-4E0E-8352-1A5F2C8E97A5}"/>
+                <a16:creationId xmlns:a16="http://schemas.microsoft.com/office/drawing/2014/main" id="{BB032F8A-84E2-4AC6-BA3D-A9D1A57D65B1}"/>
               </a:ext>
             </a:extLst>
           </p:cNvPr>
@@ -16749,7 +16507,7 @@
           <p:cNvPr id="9" name="">
             <a:extLst xmlns:a="http://schemas.openxmlformats.org/drawingml/2006/main">
               <a:ext uri="{FF2B5EF4-FFF2-40B4-BE49-F238E27FC236}">
-                <a16:creationId xmlns:a16="http://schemas.microsoft.com/office/drawing/2014/main" id="{752CA161-2663-4BD9-8731-D610DC4C7993}"/>
+                <a16:creationId xmlns:a16="http://schemas.microsoft.com/office/drawing/2014/main" id="{8C2F87B2-EC0C-41A9-91E5-4F7C746F7C8B}"/>
               </a:ext>
             </a:extLst>
           </p:cNvPr>
@@ -16870,7 +16628,7 @@
           <p:cNvPr id="10" name="">
             <a:extLst xmlns:a="http://schemas.openxmlformats.org/drawingml/2006/main">
               <a:ext uri="{FF2B5EF4-FFF2-40B4-BE49-F238E27FC236}">
-                <a16:creationId xmlns:a16="http://schemas.microsoft.com/office/drawing/2014/main" id="{51F25D39-CE00-4D09-B30C-C3050FB2833B}"/>
+                <a16:creationId xmlns:a16="http://schemas.microsoft.com/office/drawing/2014/main" id="{5AA793EE-F53B-4C1F-A5A7-B13BC49C817C}"/>
               </a:ext>
             </a:extLst>
           </p:cNvPr>
@@ -16903,7 +16661,7 @@
           <p:cNvPr id="11" name="">
             <a:extLst xmlns:a="http://schemas.openxmlformats.org/drawingml/2006/main">
               <a:ext uri="{FF2B5EF4-FFF2-40B4-BE49-F238E27FC236}">
-                <a16:creationId xmlns:a16="http://schemas.microsoft.com/office/drawing/2014/main" id="{613488F3-2122-438D-94F7-197D5DA7ADA4}"/>
+                <a16:creationId xmlns:a16="http://schemas.microsoft.com/office/drawing/2014/main" id="{3D21B943-F116-4655-BFCB-FA55DA2725D6}"/>
               </a:ext>
             </a:extLst>
           </p:cNvPr>
@@ -17024,7 +16782,7 @@
           <p:cNvPr id="12" name="">
             <a:extLst xmlns:a="http://schemas.openxmlformats.org/drawingml/2006/main">
               <a:ext uri="{FF2B5EF4-FFF2-40B4-BE49-F238E27FC236}">
-                <a16:creationId xmlns:a16="http://schemas.microsoft.com/office/drawing/2014/main" id="{E2258011-DEF9-4282-9FC5-B2D3FE1FDC53}"/>
+                <a16:creationId xmlns:a16="http://schemas.microsoft.com/office/drawing/2014/main" id="{EF4AD4F2-CD3E-419D-BA53-6102FE24DBF2}"/>
               </a:ext>
             </a:extLst>
           </p:cNvPr>
@@ -17057,7 +16815,7 @@
           <p:cNvPr id="13" name="">
             <a:extLst xmlns:a="http://schemas.openxmlformats.org/drawingml/2006/main">
               <a:ext uri="{FF2B5EF4-FFF2-40B4-BE49-F238E27FC236}">
-                <a16:creationId xmlns:a16="http://schemas.microsoft.com/office/drawing/2014/main" id="{71205170-358F-40D5-BFE2-44F681D1B0C3}"/>
+                <a16:creationId xmlns:a16="http://schemas.microsoft.com/office/drawing/2014/main" id="{35DF6165-1429-4BC5-A281-C55F907EA425}"/>
               </a:ext>
             </a:extLst>
           </p:cNvPr>
@@ -17178,7 +16936,7 @@
           <p:cNvPr id="14" name="">
             <a:extLst xmlns:a="http://schemas.openxmlformats.org/drawingml/2006/main">
               <a:ext uri="{FF2B5EF4-FFF2-40B4-BE49-F238E27FC236}">
-                <a16:creationId xmlns:a16="http://schemas.microsoft.com/office/drawing/2014/main" id="{13609130-BB02-4C07-A50B-53C319169172}"/>
+                <a16:creationId xmlns:a16="http://schemas.microsoft.com/office/drawing/2014/main" id="{380EA713-1FD5-4F37-B21C-DB60DA15A199}"/>
               </a:ext>
             </a:extLst>
           </p:cNvPr>
@@ -17211,7 +16969,7 @@
           <p:cNvPr id="15" name="">
             <a:extLst xmlns:a="http://schemas.openxmlformats.org/drawingml/2006/main">
               <a:ext uri="{FF2B5EF4-FFF2-40B4-BE49-F238E27FC236}">
-                <a16:creationId xmlns:a16="http://schemas.microsoft.com/office/drawing/2014/main" id="{24602BD2-6029-4858-AB16-4FA60B06ACC7}"/>
+                <a16:creationId xmlns:a16="http://schemas.microsoft.com/office/drawing/2014/main" id="{C18C17EC-A3C4-4028-B628-F4B30ED85D50}"/>
               </a:ext>
             </a:extLst>
           </p:cNvPr>
@@ -17332,7 +17090,7 @@
           <p:cNvPr id="16" name="">
             <a:extLst xmlns:a="http://schemas.openxmlformats.org/drawingml/2006/main">
               <a:ext uri="{FF2B5EF4-FFF2-40B4-BE49-F238E27FC236}">
-                <a16:creationId xmlns:a16="http://schemas.microsoft.com/office/drawing/2014/main" id="{77403574-2422-4CB6-90C8-7333ACAF0D21}"/>
+                <a16:creationId xmlns:a16="http://schemas.microsoft.com/office/drawing/2014/main" id="{A92F5F90-60DE-444C-BD8E-9339D32D2D87}"/>
               </a:ext>
             </a:extLst>
           </p:cNvPr>
@@ -17453,7 +17211,7 @@
           <p:cNvPr id="17" name="">
             <a:extLst xmlns:a="http://schemas.openxmlformats.org/drawingml/2006/main">
               <a:ext uri="{FF2B5EF4-FFF2-40B4-BE49-F238E27FC236}">
-                <a16:creationId xmlns:a16="http://schemas.microsoft.com/office/drawing/2014/main" id="{723AC6AE-3842-4ECB-B599-EB5AFCA915DF}"/>
+                <a16:creationId xmlns:a16="http://schemas.microsoft.com/office/drawing/2014/main" id="{AE237A6B-1BE9-4538-A682-54D2DDF920B2}"/>
               </a:ext>
             </a:extLst>
           </p:cNvPr>
@@ -17488,7 +17246,7 @@
           <p:cNvPr id="18" name="">
             <a:extLst xmlns:a="http://schemas.openxmlformats.org/drawingml/2006/main">
               <a:ext uri="{FF2B5EF4-FFF2-40B4-BE49-F238E27FC236}">
-                <a16:creationId xmlns:a16="http://schemas.microsoft.com/office/drawing/2014/main" id="{521B3744-AEA9-42D0-8801-0FF57392FB34}"/>
+                <a16:creationId xmlns:a16="http://schemas.microsoft.com/office/drawing/2014/main" id="{B135812E-CBA9-4E04-B370-B950F3F9D99C}"/>
               </a:ext>
             </a:extLst>
           </p:cNvPr>
@@ -17643,7 +17401,7 @@
           <p:cNvPr id="19" name="">
             <a:extLst xmlns:a="http://schemas.openxmlformats.org/drawingml/2006/main">
               <a:ext uri="{FF2B5EF4-FFF2-40B4-BE49-F238E27FC236}">
-                <a16:creationId xmlns:a16="http://schemas.microsoft.com/office/drawing/2014/main" id="{C8F2D223-A1CF-423A-8B6C-4D7890974856}"/>
+                <a16:creationId xmlns:a16="http://schemas.microsoft.com/office/drawing/2014/main" id="{F698186D-DE3D-4CF0-9273-5BDDD432BCA1}"/>
               </a:ext>
             </a:extLst>
           </p:cNvPr>
@@ -17678,7 +17436,7 @@
           <p:cNvPr id="20" name="">
             <a:extLst xmlns:a="http://schemas.openxmlformats.org/drawingml/2006/main">
               <a:ext uri="{FF2B5EF4-FFF2-40B4-BE49-F238E27FC236}">
-                <a16:creationId xmlns:a16="http://schemas.microsoft.com/office/drawing/2014/main" id="{0A88E143-7848-41FB-B29F-9E6CE095A57C}"/>
+                <a16:creationId xmlns:a16="http://schemas.microsoft.com/office/drawing/2014/main" id="{904579BB-EAA5-4E66-AF2A-29C2F88FCA7F}"/>
               </a:ext>
             </a:extLst>
           </p:cNvPr>
@@ -17833,7 +17591,7 @@
           <p:cNvPr id="21" name="">
             <a:extLst xmlns:a="http://schemas.openxmlformats.org/drawingml/2006/main">
               <a:ext uri="{FF2B5EF4-FFF2-40B4-BE49-F238E27FC236}">
-                <a16:creationId xmlns:a16="http://schemas.microsoft.com/office/drawing/2014/main" id="{0297278A-4FA7-4307-8428-F5A12E6A1E47}"/>
+                <a16:creationId xmlns:a16="http://schemas.microsoft.com/office/drawing/2014/main" id="{48E0F8AC-463D-4344-8CB2-E23F6F522359}"/>
               </a:ext>
             </a:extLst>
           </p:cNvPr>
@@ -17868,7 +17626,7 @@
           <p:cNvPr id="22" name="">
             <a:extLst xmlns:a="http://schemas.openxmlformats.org/drawingml/2006/main">
               <a:ext uri="{FF2B5EF4-FFF2-40B4-BE49-F238E27FC236}">
-                <a16:creationId xmlns:a16="http://schemas.microsoft.com/office/drawing/2014/main" id="{EA9EFE96-86CB-4528-AE18-61C64A25FD65}"/>
+                <a16:creationId xmlns:a16="http://schemas.microsoft.com/office/drawing/2014/main" id="{1A6D02C5-890F-40CE-85B2-AB2D29C11320}"/>
               </a:ext>
             </a:extLst>
           </p:cNvPr>
@@ -18023,7 +17781,7 @@
           <p:cNvPr id="23" name="">
             <a:extLst xmlns:a="http://schemas.openxmlformats.org/drawingml/2006/main">
               <a:ext uri="{FF2B5EF4-FFF2-40B4-BE49-F238E27FC236}">
-                <a16:creationId xmlns:a16="http://schemas.microsoft.com/office/drawing/2014/main" id="{8BDFB393-CE1C-4C50-9074-C2CD444956CD}"/>
+                <a16:creationId xmlns:a16="http://schemas.microsoft.com/office/drawing/2014/main" id="{37634747-7D0B-452C-8226-C6CA427B769D}"/>
               </a:ext>
             </a:extLst>
           </p:cNvPr>
@@ -18142,7 +17900,7 @@
     </p:spTree>
     <p:extLst>
       <p:ext uri="{BB962C8B-B14F-4D97-AF65-F5344CB8AC3E}">
-        <p14:creationId xmlns:p14="http://schemas.microsoft.com/office/powerpoint/2010/main" val="738339871"/>
+        <p14:creationId xmlns:p14="http://schemas.microsoft.com/office/powerpoint/2010/main" val="125174191"/>
       </p:ext>
     </p:extLst>
   </p:cSld>
@@ -18173,7 +17931,7 @@
           <p:cNvPr id="32" name="">
             <a:extLst xmlns:a="http://schemas.openxmlformats.org/drawingml/2006/main">
               <a:ext uri="{FF2B5EF4-FFF2-40B4-BE49-F238E27FC236}">
-                <a16:creationId xmlns:a16="http://schemas.microsoft.com/office/drawing/2014/main" id="{D654DF3E-E172-4D82-B9DB-626688EE015F}"/>
+                <a16:creationId xmlns:a16="http://schemas.microsoft.com/office/drawing/2014/main" id="{CE6C8E14-D0AF-4918-9B50-4BD0C29033D4}"/>
               </a:ext>
             </a:extLst>
           </p:cNvPr>
@@ -18204,7 +17962,7 @@
           <p:cNvPr id="2" name="">
             <a:extLst xmlns:a="http://schemas.openxmlformats.org/drawingml/2006/main">
               <a:ext uri="{FF2B5EF4-FFF2-40B4-BE49-F238E27FC236}">
-                <a16:creationId xmlns:a16="http://schemas.microsoft.com/office/drawing/2014/main" id="{9DEAA86E-7390-4BCE-A327-7114335E44F0}"/>
+                <a16:creationId xmlns:a16="http://schemas.microsoft.com/office/drawing/2014/main" id="{0EFAF8A0-ACA5-411A-B37F-A3312B6EFAAE}"/>
               </a:ext>
             </a:extLst>
           </p:cNvPr>
@@ -18325,7 +18083,7 @@
           <p:cNvPr id="3" name="">
             <a:extLst xmlns:a="http://schemas.openxmlformats.org/drawingml/2006/main">
               <a:ext uri="{FF2B5EF4-FFF2-40B4-BE49-F238E27FC236}">
-                <a16:creationId xmlns:a16="http://schemas.microsoft.com/office/drawing/2014/main" id="{A0398917-D3DF-4DF9-A211-478D48975305}"/>
+                <a16:creationId xmlns:a16="http://schemas.microsoft.com/office/drawing/2014/main" id="{45249AD4-49F1-4E64-BF64-98077ECE5D31}"/>
               </a:ext>
             </a:extLst>
           </p:cNvPr>
@@ -18446,7 +18204,7 @@
           <p:cNvPr id="4" name="">
             <a:extLst xmlns:a="http://schemas.openxmlformats.org/drawingml/2006/main">
               <a:ext uri="{FF2B5EF4-FFF2-40B4-BE49-F238E27FC236}">
-                <a16:creationId xmlns:a16="http://schemas.microsoft.com/office/drawing/2014/main" id="{3BEE116F-A74F-4D41-B01A-044EFF59B326}"/>
+                <a16:creationId xmlns:a16="http://schemas.microsoft.com/office/drawing/2014/main" id="{7A3B96A9-BF89-4C21-9C22-41F8A09A6C20}"/>
               </a:ext>
             </a:extLst>
           </p:cNvPr>
@@ -18477,7 +18235,7 @@
           <p:cNvPr id="5" name="">
             <a:extLst xmlns:a="http://schemas.openxmlformats.org/drawingml/2006/main">
               <a:ext uri="{FF2B5EF4-FFF2-40B4-BE49-F238E27FC236}">
-                <a16:creationId xmlns:a16="http://schemas.microsoft.com/office/drawing/2014/main" id="{46592492-2EC9-4C4E-B6AD-C19032F79EFE}"/>
+                <a16:creationId xmlns:a16="http://schemas.microsoft.com/office/drawing/2014/main" id="{760D0EC3-115A-489E-BC3A-01634B1C5F3A}"/>
               </a:ext>
             </a:extLst>
           </p:cNvPr>
@@ -18598,7 +18356,7 @@
           <p:cNvPr id="6" name="">
             <a:extLst xmlns:a="http://schemas.openxmlformats.org/drawingml/2006/main">
               <a:ext uri="{FF2B5EF4-FFF2-40B4-BE49-F238E27FC236}">
-                <a16:creationId xmlns:a16="http://schemas.microsoft.com/office/drawing/2014/main" id="{C482465F-EA45-4B4F-ACF5-0AC7E540F046}"/>
+                <a16:creationId xmlns:a16="http://schemas.microsoft.com/office/drawing/2014/main" id="{0D2280C7-8C04-4037-9CB3-287298278C2A}"/>
               </a:ext>
             </a:extLst>
           </p:cNvPr>
@@ -18719,7 +18477,7 @@
           <p:cNvPr id="7" name="">
             <a:extLst xmlns:a="http://schemas.openxmlformats.org/drawingml/2006/main">
               <a:ext uri="{FF2B5EF4-FFF2-40B4-BE49-F238E27FC236}">
-                <a16:creationId xmlns:a16="http://schemas.microsoft.com/office/drawing/2014/main" id="{FFA5D910-C707-4AE3-81B4-3D05332F4FEE}"/>
+                <a16:creationId xmlns:a16="http://schemas.microsoft.com/office/drawing/2014/main" id="{3243FCFC-4152-42FB-B2C2-8A28257D0203}"/>
               </a:ext>
             </a:extLst>
           </p:cNvPr>
@@ -18750,7 +18508,7 @@
           <p:cNvPr id="8" name="">
             <a:extLst xmlns:a="http://schemas.openxmlformats.org/drawingml/2006/main">
               <a:ext uri="{FF2B5EF4-FFF2-40B4-BE49-F238E27FC236}">
-                <a16:creationId xmlns:a16="http://schemas.microsoft.com/office/drawing/2014/main" id="{199ACADE-C81C-4C16-BC47-26DAE9C8A7E4}"/>
+                <a16:creationId xmlns:a16="http://schemas.microsoft.com/office/drawing/2014/main" id="{A3C4B3F9-BAE6-44FC-BCC6-9EC9AD03D17C}"/>
               </a:ext>
             </a:extLst>
           </p:cNvPr>
@@ -18871,7 +18629,7 @@
           <p:cNvPr id="9" name="">
             <a:extLst xmlns:a="http://schemas.openxmlformats.org/drawingml/2006/main">
               <a:ext uri="{FF2B5EF4-FFF2-40B4-BE49-F238E27FC236}">
-                <a16:creationId xmlns:a16="http://schemas.microsoft.com/office/drawing/2014/main" id="{CA203B64-10C6-47FD-8090-5834DDD0E08F}"/>
+                <a16:creationId xmlns:a16="http://schemas.microsoft.com/office/drawing/2014/main" id="{8D0527CD-41D7-4AAE-A74B-A6E9A6A89C07}"/>
               </a:ext>
             </a:extLst>
           </p:cNvPr>
@@ -18992,7 +18750,7 @@
           <p:cNvPr id="10" name="">
             <a:extLst xmlns:a="http://schemas.openxmlformats.org/drawingml/2006/main">
               <a:ext uri="{FF2B5EF4-FFF2-40B4-BE49-F238E27FC236}">
-                <a16:creationId xmlns:a16="http://schemas.microsoft.com/office/drawing/2014/main" id="{0F38045F-6164-451F-8925-8AD63FF94EF9}"/>
+                <a16:creationId xmlns:a16="http://schemas.microsoft.com/office/drawing/2014/main" id="{07396BEA-9568-4E2C-BA84-F165FB72C662}"/>
               </a:ext>
             </a:extLst>
           </p:cNvPr>
@@ -19113,7 +18871,7 @@
           <p:cNvPr id="11" name="">
             <a:extLst xmlns:a="http://schemas.openxmlformats.org/drawingml/2006/main">
               <a:ext uri="{FF2B5EF4-FFF2-40B4-BE49-F238E27FC236}">
-                <a16:creationId xmlns:a16="http://schemas.microsoft.com/office/drawing/2014/main" id="{C7842EFB-43BB-4624-8B1C-EB8CF3B0002E}"/>
+                <a16:creationId xmlns:a16="http://schemas.microsoft.com/office/drawing/2014/main" id="{5B698F6D-6153-4DCD-9000-3BA0F4EF8A37}"/>
               </a:ext>
             </a:extLst>
           </p:cNvPr>
@@ -19144,7 +18902,7 @@
           <p:cNvPr id="12" name="">
             <a:extLst xmlns:a="http://schemas.openxmlformats.org/drawingml/2006/main">
               <a:ext uri="{FF2B5EF4-FFF2-40B4-BE49-F238E27FC236}">
-                <a16:creationId xmlns:a16="http://schemas.microsoft.com/office/drawing/2014/main" id="{388C5EAB-CFD8-4B36-ACA5-3E91C15E6427}"/>
+                <a16:creationId xmlns:a16="http://schemas.microsoft.com/office/drawing/2014/main" id="{B32AEB6F-0F83-49A2-85BB-E846E491DA0F}"/>
               </a:ext>
             </a:extLst>
           </p:cNvPr>
@@ -19265,7 +19023,7 @@
           <p:cNvPr id="13" name="">
             <a:extLst xmlns:a="http://schemas.openxmlformats.org/drawingml/2006/main">
               <a:ext uri="{FF2B5EF4-FFF2-40B4-BE49-F238E27FC236}">
-                <a16:creationId xmlns:a16="http://schemas.microsoft.com/office/drawing/2014/main" id="{C75CFBBD-0779-441D-8FBF-DD669B2CBE7C}"/>
+                <a16:creationId xmlns:a16="http://schemas.microsoft.com/office/drawing/2014/main" id="{582B224C-5E67-4E68-93E3-902DC16AFCA3}"/>
               </a:ext>
             </a:extLst>
           </p:cNvPr>
@@ -19386,7 +19144,7 @@
           <p:cNvPr id="14" name="">
             <a:extLst xmlns:a="http://schemas.openxmlformats.org/drawingml/2006/main">
               <a:ext uri="{FF2B5EF4-FFF2-40B4-BE49-F238E27FC236}">
-                <a16:creationId xmlns:a16="http://schemas.microsoft.com/office/drawing/2014/main" id="{959C07C3-21DD-4274-B2DB-004D95BBB898}"/>
+                <a16:creationId xmlns:a16="http://schemas.microsoft.com/office/drawing/2014/main" id="{06AEFA82-AC79-4F84-9CF9-E74F6FD85631}"/>
               </a:ext>
             </a:extLst>
           </p:cNvPr>
@@ -19507,7 +19265,7 @@
           <p:cNvPr id="15" name="">
             <a:extLst xmlns:a="http://schemas.openxmlformats.org/drawingml/2006/main">
               <a:ext uri="{FF2B5EF4-FFF2-40B4-BE49-F238E27FC236}">
-                <a16:creationId xmlns:a16="http://schemas.microsoft.com/office/drawing/2014/main" id="{9A9BD628-2AE8-4FB7-952F-6CE362844B8F}"/>
+                <a16:creationId xmlns:a16="http://schemas.microsoft.com/office/drawing/2014/main" id="{CB8C59D2-DEFB-4D2C-A4E7-FE0C01D506D5}"/>
               </a:ext>
             </a:extLst>
           </p:cNvPr>
@@ -19538,7 +19296,7 @@
           <p:cNvPr id="16" name="">
             <a:extLst xmlns:a="http://schemas.openxmlformats.org/drawingml/2006/main">
               <a:ext uri="{FF2B5EF4-FFF2-40B4-BE49-F238E27FC236}">
-                <a16:creationId xmlns:a16="http://schemas.microsoft.com/office/drawing/2014/main" id="{9DC04E5F-6BFA-40E1-9294-EE260D4F9441}"/>
+                <a16:creationId xmlns:a16="http://schemas.microsoft.com/office/drawing/2014/main" id="{8141F32B-DA2E-4A8A-99B9-B70C9FB64E87}"/>
               </a:ext>
             </a:extLst>
           </p:cNvPr>
@@ -19659,7 +19417,7 @@
           <p:cNvPr id="17" name="">
             <a:extLst xmlns:a="http://schemas.openxmlformats.org/drawingml/2006/main">
               <a:ext uri="{FF2B5EF4-FFF2-40B4-BE49-F238E27FC236}">
-                <a16:creationId xmlns:a16="http://schemas.microsoft.com/office/drawing/2014/main" id="{5FC475B7-40DC-419F-8D30-C622CC7EE1AF}"/>
+                <a16:creationId xmlns:a16="http://schemas.microsoft.com/office/drawing/2014/main" id="{4E08DB15-527A-4B86-BDAB-0A6FF4E52E67}"/>
               </a:ext>
             </a:extLst>
           </p:cNvPr>
@@ -19780,7 +19538,7 @@
           <p:cNvPr id="18" name="">
             <a:extLst xmlns:a="http://schemas.openxmlformats.org/drawingml/2006/main">
               <a:ext uri="{FF2B5EF4-FFF2-40B4-BE49-F238E27FC236}">
-                <a16:creationId xmlns:a16="http://schemas.microsoft.com/office/drawing/2014/main" id="{D91B6923-F60E-40AB-9EE2-8E36F7178428}"/>
+                <a16:creationId xmlns:a16="http://schemas.microsoft.com/office/drawing/2014/main" id="{9B95E510-984C-4B8D-888F-0E7DA37FCE36}"/>
               </a:ext>
             </a:extLst>
           </p:cNvPr>
@@ -19901,7 +19659,7 @@
           <p:cNvPr id="19" name="">
             <a:extLst xmlns:a="http://schemas.openxmlformats.org/drawingml/2006/main">
               <a:ext uri="{FF2B5EF4-FFF2-40B4-BE49-F238E27FC236}">
-                <a16:creationId xmlns:a16="http://schemas.microsoft.com/office/drawing/2014/main" id="{89B17B54-A257-4487-8DAF-638031DA757D}"/>
+                <a16:creationId xmlns:a16="http://schemas.microsoft.com/office/drawing/2014/main" id="{01F4D2EE-9BDB-4BD7-B4EC-6A9E6001CD90}"/>
               </a:ext>
             </a:extLst>
           </p:cNvPr>
@@ -19932,7 +19690,7 @@
           <p:cNvPr id="20" name="">
             <a:extLst xmlns:a="http://schemas.openxmlformats.org/drawingml/2006/main">
               <a:ext uri="{FF2B5EF4-FFF2-40B4-BE49-F238E27FC236}">
-                <a16:creationId xmlns:a16="http://schemas.microsoft.com/office/drawing/2014/main" id="{6BDB063B-FB26-4420-9F60-4BD011D35D75}"/>
+                <a16:creationId xmlns:a16="http://schemas.microsoft.com/office/drawing/2014/main" id="{1C5FDB16-10DD-4027-950C-A6F142C733CB}"/>
               </a:ext>
             </a:extLst>
           </p:cNvPr>
@@ -20053,7 +19811,7 @@
           <p:cNvPr id="21" name="">
             <a:extLst xmlns:a="http://schemas.openxmlformats.org/drawingml/2006/main">
               <a:ext uri="{FF2B5EF4-FFF2-40B4-BE49-F238E27FC236}">
-                <a16:creationId xmlns:a16="http://schemas.microsoft.com/office/drawing/2014/main" id="{4FF6E802-B2C4-460D-BF83-690279E49B39}"/>
+                <a16:creationId xmlns:a16="http://schemas.microsoft.com/office/drawing/2014/main" id="{DB0CCCE5-1730-44A8-B7EE-3E0F0CA02B09}"/>
               </a:ext>
             </a:extLst>
           </p:cNvPr>
@@ -20174,7 +19932,7 @@
           <p:cNvPr id="22" name="">
             <a:extLst xmlns:a="http://schemas.openxmlformats.org/drawingml/2006/main">
               <a:ext uri="{FF2B5EF4-FFF2-40B4-BE49-F238E27FC236}">
-                <a16:creationId xmlns:a16="http://schemas.microsoft.com/office/drawing/2014/main" id="{E1A9A2B8-ADC9-45D1-8B59-38F2D0F6E0F5}"/>
+                <a16:creationId xmlns:a16="http://schemas.microsoft.com/office/drawing/2014/main" id="{F2B4970B-E20C-445F-A203-F38B75F50A8C}"/>
               </a:ext>
             </a:extLst>
           </p:cNvPr>
@@ -20295,7 +20053,7 @@
           <p:cNvPr id="23" name="">
             <a:extLst xmlns:a="http://schemas.openxmlformats.org/drawingml/2006/main">
               <a:ext uri="{FF2B5EF4-FFF2-40B4-BE49-F238E27FC236}">
-                <a16:creationId xmlns:a16="http://schemas.microsoft.com/office/drawing/2014/main" id="{C690DEFB-2AF9-4235-9C0D-406332C97446}"/>
+                <a16:creationId xmlns:a16="http://schemas.microsoft.com/office/drawing/2014/main" id="{50B66105-AADB-4348-8FC7-5419C9265DB6}"/>
               </a:ext>
             </a:extLst>
           </p:cNvPr>
@@ -20326,7 +20084,7 @@
           <p:cNvPr id="24" name="">
             <a:extLst xmlns:a="http://schemas.openxmlformats.org/drawingml/2006/main">
               <a:ext uri="{FF2B5EF4-FFF2-40B4-BE49-F238E27FC236}">
-                <a16:creationId xmlns:a16="http://schemas.microsoft.com/office/drawing/2014/main" id="{F879A7DD-FC94-4EED-8716-5206357A3A2E}"/>
+                <a16:creationId xmlns:a16="http://schemas.microsoft.com/office/drawing/2014/main" id="{9361D0FD-9D94-4A9B-B108-E893FCA3A984}"/>
               </a:ext>
             </a:extLst>
           </p:cNvPr>
@@ -20447,7 +20205,7 @@
           <p:cNvPr id="25" name="">
             <a:extLst xmlns:a="http://schemas.openxmlformats.org/drawingml/2006/main">
               <a:ext uri="{FF2B5EF4-FFF2-40B4-BE49-F238E27FC236}">
-                <a16:creationId xmlns:a16="http://schemas.microsoft.com/office/drawing/2014/main" id="{9CCB4E28-C1D2-44BB-81B9-9F97B048DC1E}"/>
+                <a16:creationId xmlns:a16="http://schemas.microsoft.com/office/drawing/2014/main" id="{723E962C-D00C-42CC-AC8B-8322E6AC0F0F}"/>
               </a:ext>
             </a:extLst>
           </p:cNvPr>
@@ -20568,7 +20326,7 @@
           <p:cNvPr id="26" name="">
             <a:extLst xmlns:a="http://schemas.openxmlformats.org/drawingml/2006/main">
               <a:ext uri="{FF2B5EF4-FFF2-40B4-BE49-F238E27FC236}">
-                <a16:creationId xmlns:a16="http://schemas.microsoft.com/office/drawing/2014/main" id="{6C47DDBC-8D19-4ADB-80D0-351AE166B0B2}"/>
+                <a16:creationId xmlns:a16="http://schemas.microsoft.com/office/drawing/2014/main" id="{4D09CC2F-9B26-4160-AA83-AD0B7B9DEFCD}"/>
               </a:ext>
             </a:extLst>
           </p:cNvPr>
@@ -20689,7 +20447,7 @@
           <p:cNvPr id="27" name="">
             <a:extLst xmlns:a="http://schemas.openxmlformats.org/drawingml/2006/main">
               <a:ext uri="{FF2B5EF4-FFF2-40B4-BE49-F238E27FC236}">
-                <a16:creationId xmlns:a16="http://schemas.microsoft.com/office/drawing/2014/main" id="{CE5AD039-D4A6-4E69-95E2-B6766F251217}"/>
+                <a16:creationId xmlns:a16="http://schemas.microsoft.com/office/drawing/2014/main" id="{6FD73913-46BF-481D-A327-58083EA67638}"/>
               </a:ext>
             </a:extLst>
           </p:cNvPr>
@@ -20720,7 +20478,7 @@
           <p:cNvPr id="28" name="">
             <a:extLst xmlns:a="http://schemas.openxmlformats.org/drawingml/2006/main">
               <a:ext uri="{FF2B5EF4-FFF2-40B4-BE49-F238E27FC236}">
-                <a16:creationId xmlns:a16="http://schemas.microsoft.com/office/drawing/2014/main" id="{9740FBFA-01DB-4BFF-A979-C6FDA862B45F}"/>
+                <a16:creationId xmlns:a16="http://schemas.microsoft.com/office/drawing/2014/main" id="{0FE9BB02-4799-4A7C-B2A2-D1CCBA965BAA}"/>
               </a:ext>
             </a:extLst>
           </p:cNvPr>
@@ -20841,7 +20599,7 @@
           <p:cNvPr id="29" name="">
             <a:extLst xmlns:a="http://schemas.openxmlformats.org/drawingml/2006/main">
               <a:ext uri="{FF2B5EF4-FFF2-40B4-BE49-F238E27FC236}">
-                <a16:creationId xmlns:a16="http://schemas.microsoft.com/office/drawing/2014/main" id="{E22171EB-0810-490A-AD0B-B982C0AE1937}"/>
+                <a16:creationId xmlns:a16="http://schemas.microsoft.com/office/drawing/2014/main" id="{26601A39-A366-45FB-BB84-ED92D01867D5}"/>
               </a:ext>
             </a:extLst>
           </p:cNvPr>
@@ -20962,7 +20720,7 @@
           <p:cNvPr id="30" name="">
             <a:extLst xmlns:a="http://schemas.openxmlformats.org/drawingml/2006/main">
               <a:ext uri="{FF2B5EF4-FFF2-40B4-BE49-F238E27FC236}">
-                <a16:creationId xmlns:a16="http://schemas.microsoft.com/office/drawing/2014/main" id="{71DFB305-5F30-4F35-8413-CC19B7604BE7}"/>
+                <a16:creationId xmlns:a16="http://schemas.microsoft.com/office/drawing/2014/main" id="{26FB746E-5DE2-4BC5-AB38-229B3588B826}"/>
               </a:ext>
             </a:extLst>
           </p:cNvPr>
@@ -21083,7 +20841,7 @@
           <p:cNvPr id="31" name="">
             <a:extLst xmlns:a="http://schemas.openxmlformats.org/drawingml/2006/main">
               <a:ext uri="{FF2B5EF4-FFF2-40B4-BE49-F238E27FC236}">
-                <a16:creationId xmlns:a16="http://schemas.microsoft.com/office/drawing/2014/main" id="{401CA02C-8983-45CC-92D7-AA5252894EC3}"/>
+                <a16:creationId xmlns:a16="http://schemas.microsoft.com/office/drawing/2014/main" id="{C850FF39-DAFC-411E-8636-1CE19BC317CB}"/>
               </a:ext>
             </a:extLst>
           </p:cNvPr>
@@ -21202,7 +20960,7 @@
     </p:spTree>
     <p:extLst>
       <p:ext uri="{BB962C8B-B14F-4D97-AF65-F5344CB8AC3E}">
-        <p14:creationId xmlns:p14="http://schemas.microsoft.com/office/powerpoint/2010/main" val="42073644"/>
+        <p14:creationId xmlns:p14="http://schemas.microsoft.com/office/powerpoint/2010/main" val="113125314"/>
       </p:ext>
     </p:extLst>
   </p:cSld>
@@ -21233,7 +20991,7 @@
           <p:cNvPr id="32" name="">
             <a:extLst xmlns:a="http://schemas.openxmlformats.org/drawingml/2006/main">
               <a:ext uri="{FF2B5EF4-FFF2-40B4-BE49-F238E27FC236}">
-                <a16:creationId xmlns:a16="http://schemas.microsoft.com/office/drawing/2014/main" id="{7F3FE768-FD98-4D6D-9BA4-F68D8DA9DB25}"/>
+                <a16:creationId xmlns:a16="http://schemas.microsoft.com/office/drawing/2014/main" id="{7804CCD0-F516-4C5A-A101-AA9B0F5DC3AB}"/>
               </a:ext>
             </a:extLst>
           </p:cNvPr>
@@ -21264,7 +21022,7 @@
           <p:cNvPr id="2" name="">
             <a:extLst xmlns:a="http://schemas.openxmlformats.org/drawingml/2006/main">
               <a:ext uri="{FF2B5EF4-FFF2-40B4-BE49-F238E27FC236}">
-                <a16:creationId xmlns:a16="http://schemas.microsoft.com/office/drawing/2014/main" id="{39D63645-BF4E-460E-A3A5-CEDBA7E74198}"/>
+                <a16:creationId xmlns:a16="http://schemas.microsoft.com/office/drawing/2014/main" id="{EE3D5BCE-FC42-454E-B1DD-D65772E216FC}"/>
               </a:ext>
             </a:extLst>
           </p:cNvPr>
@@ -21385,7 +21143,7 @@
           <p:cNvPr id="3" name="">
             <a:extLst xmlns:a="http://schemas.openxmlformats.org/drawingml/2006/main">
               <a:ext uri="{FF2B5EF4-FFF2-40B4-BE49-F238E27FC236}">
-                <a16:creationId xmlns:a16="http://schemas.microsoft.com/office/drawing/2014/main" id="{FD8F9C7A-21ED-4057-927F-7347CFDAB626}"/>
+                <a16:creationId xmlns:a16="http://schemas.microsoft.com/office/drawing/2014/main" id="{ACAF65B3-CC03-4FDA-839E-A12B2D0B022F}"/>
               </a:ext>
             </a:extLst>
           </p:cNvPr>
@@ -21506,7 +21264,7 @@
           <p:cNvPr id="4" name="">
             <a:extLst xmlns:a="http://schemas.openxmlformats.org/drawingml/2006/main">
               <a:ext uri="{FF2B5EF4-FFF2-40B4-BE49-F238E27FC236}">
-                <a16:creationId xmlns:a16="http://schemas.microsoft.com/office/drawing/2014/main" id="{391BFBF7-3760-4E0B-BF43-3792A9F48840}"/>
+                <a16:creationId xmlns:a16="http://schemas.microsoft.com/office/drawing/2014/main" id="{C4C577AA-488A-4D04-88C7-78E83E354E1C}"/>
               </a:ext>
             </a:extLst>
           </p:cNvPr>
@@ -21537,7 +21295,7 @@
           <p:cNvPr id="5" name="">
             <a:extLst xmlns:a="http://schemas.openxmlformats.org/drawingml/2006/main">
               <a:ext uri="{FF2B5EF4-FFF2-40B4-BE49-F238E27FC236}">
-                <a16:creationId xmlns:a16="http://schemas.microsoft.com/office/drawing/2014/main" id="{AC99B063-0053-40C6-A13E-E99554DAD8A0}"/>
+                <a16:creationId xmlns:a16="http://schemas.microsoft.com/office/drawing/2014/main" id="{68C80AC9-51A7-43CE-91E1-3AD12A580EB8}"/>
               </a:ext>
             </a:extLst>
           </p:cNvPr>
@@ -21658,7 +21416,7 @@
           <p:cNvPr id="6" name="">
             <a:extLst xmlns:a="http://schemas.openxmlformats.org/drawingml/2006/main">
               <a:ext uri="{FF2B5EF4-FFF2-40B4-BE49-F238E27FC236}">
-                <a16:creationId xmlns:a16="http://schemas.microsoft.com/office/drawing/2014/main" id="{EAE6312F-BCB2-4937-B4DB-0BF4FA814980}"/>
+                <a16:creationId xmlns:a16="http://schemas.microsoft.com/office/drawing/2014/main" id="{4E03C401-0380-484D-825F-3C2039B01FA8}"/>
               </a:ext>
             </a:extLst>
           </p:cNvPr>
@@ -21779,7 +21537,7 @@
           <p:cNvPr id="7" name="">
             <a:extLst xmlns:a="http://schemas.openxmlformats.org/drawingml/2006/main">
               <a:ext uri="{FF2B5EF4-FFF2-40B4-BE49-F238E27FC236}">
-                <a16:creationId xmlns:a16="http://schemas.microsoft.com/office/drawing/2014/main" id="{91564D23-3C68-4159-86C3-E47FF4922439}"/>
+                <a16:creationId xmlns:a16="http://schemas.microsoft.com/office/drawing/2014/main" id="{801EBD0A-6D87-4EB2-9FC7-F0E391814580}"/>
               </a:ext>
             </a:extLst>
           </p:cNvPr>
@@ -21900,7 +21658,7 @@
           <p:cNvPr id="8" name="">
             <a:extLst xmlns:a="http://schemas.openxmlformats.org/drawingml/2006/main">
               <a:ext uri="{FF2B5EF4-FFF2-40B4-BE49-F238E27FC236}">
-                <a16:creationId xmlns:a16="http://schemas.microsoft.com/office/drawing/2014/main" id="{9FC90AB5-7E3F-4BFE-B812-16881E54E424}"/>
+                <a16:creationId xmlns:a16="http://schemas.microsoft.com/office/drawing/2014/main" id="{5413FE0C-9046-4C35-8E60-CC347D656183}"/>
               </a:ext>
             </a:extLst>
           </p:cNvPr>
@@ -22021,7 +21779,7 @@
           <p:cNvPr id="9" name="">
             <a:extLst xmlns:a="http://schemas.openxmlformats.org/drawingml/2006/main">
               <a:ext uri="{FF2B5EF4-FFF2-40B4-BE49-F238E27FC236}">
-                <a16:creationId xmlns:a16="http://schemas.microsoft.com/office/drawing/2014/main" id="{055CB9A0-22EC-4CA0-9B9B-D6AE034C78B1}"/>
+                <a16:creationId xmlns:a16="http://schemas.microsoft.com/office/drawing/2014/main" id="{F0FAD053-7F96-4ACA-907D-89D4445567B3}"/>
               </a:ext>
             </a:extLst>
           </p:cNvPr>
@@ -22052,7 +21810,7 @@
           <p:cNvPr id="10" name="">
             <a:extLst xmlns:a="http://schemas.openxmlformats.org/drawingml/2006/main">
               <a:ext uri="{FF2B5EF4-FFF2-40B4-BE49-F238E27FC236}">
-                <a16:creationId xmlns:a16="http://schemas.microsoft.com/office/drawing/2014/main" id="{3B1F06B5-089B-4109-998B-3808A7799DD5}"/>
+                <a16:creationId xmlns:a16="http://schemas.microsoft.com/office/drawing/2014/main" id="{06F522EC-EDA8-4523-99AA-BC739F6B3C74}"/>
               </a:ext>
             </a:extLst>
           </p:cNvPr>
@@ -22173,7 +21931,7 @@
           <p:cNvPr id="11" name="">
             <a:extLst xmlns:a="http://schemas.openxmlformats.org/drawingml/2006/main">
               <a:ext uri="{FF2B5EF4-FFF2-40B4-BE49-F238E27FC236}">
-                <a16:creationId xmlns:a16="http://schemas.microsoft.com/office/drawing/2014/main" id="{55A12311-806D-4FEC-AA90-3C0FB64E76B8}"/>
+                <a16:creationId xmlns:a16="http://schemas.microsoft.com/office/drawing/2014/main" id="{D90FB341-7289-4497-B13E-CC7D4D5A8704}"/>
               </a:ext>
             </a:extLst>
           </p:cNvPr>
@@ -22294,7 +22052,7 @@
           <p:cNvPr id="12" name="">
             <a:extLst xmlns:a="http://schemas.openxmlformats.org/drawingml/2006/main">
               <a:ext uri="{FF2B5EF4-FFF2-40B4-BE49-F238E27FC236}">
-                <a16:creationId xmlns:a16="http://schemas.microsoft.com/office/drawing/2014/main" id="{52DD9C84-A9F9-4998-B551-0C1C69EF9C42}"/>
+                <a16:creationId xmlns:a16="http://schemas.microsoft.com/office/drawing/2014/main" id="{51718A37-BDFF-47DC-87A7-643DB5B69DA3}"/>
               </a:ext>
             </a:extLst>
           </p:cNvPr>
@@ -22415,7 +22173,7 @@
           <p:cNvPr id="13" name="">
             <a:extLst xmlns:a="http://schemas.openxmlformats.org/drawingml/2006/main">
               <a:ext uri="{FF2B5EF4-FFF2-40B4-BE49-F238E27FC236}">
-                <a16:creationId xmlns:a16="http://schemas.microsoft.com/office/drawing/2014/main" id="{76D3BEA2-258F-4496-A528-ADC46FACFA01}"/>
+                <a16:creationId xmlns:a16="http://schemas.microsoft.com/office/drawing/2014/main" id="{2B48F806-1993-4988-8A92-F1F1A2EC0924}"/>
               </a:ext>
             </a:extLst>
           </p:cNvPr>
@@ -22446,7 +22204,7 @@
           <p:cNvPr id="14" name="">
             <a:extLst xmlns:a="http://schemas.openxmlformats.org/drawingml/2006/main">
               <a:ext uri="{FF2B5EF4-FFF2-40B4-BE49-F238E27FC236}">
-                <a16:creationId xmlns:a16="http://schemas.microsoft.com/office/drawing/2014/main" id="{B6491633-CF0D-4FAF-B375-8F81E66538E1}"/>
+                <a16:creationId xmlns:a16="http://schemas.microsoft.com/office/drawing/2014/main" id="{3398013C-CC8E-4B5E-AB75-39780F2A38E0}"/>
               </a:ext>
             </a:extLst>
           </p:cNvPr>
@@ -22567,7 +22325,7 @@
           <p:cNvPr id="15" name="">
             <a:extLst xmlns:a="http://schemas.openxmlformats.org/drawingml/2006/main">
               <a:ext uri="{FF2B5EF4-FFF2-40B4-BE49-F238E27FC236}">
-                <a16:creationId xmlns:a16="http://schemas.microsoft.com/office/drawing/2014/main" id="{B6446510-B223-4F98-84F1-34EFDA52A0E5}"/>
+                <a16:creationId xmlns:a16="http://schemas.microsoft.com/office/drawing/2014/main" id="{71A6404F-2CDC-44A3-B464-8C546D196507}"/>
               </a:ext>
             </a:extLst>
           </p:cNvPr>
@@ -22688,7 +22446,7 @@
           <p:cNvPr id="16" name="">
             <a:extLst xmlns:a="http://schemas.openxmlformats.org/drawingml/2006/main">
               <a:ext uri="{FF2B5EF4-FFF2-40B4-BE49-F238E27FC236}">
-                <a16:creationId xmlns:a16="http://schemas.microsoft.com/office/drawing/2014/main" id="{F3997AD5-B815-40AB-B4C7-1B3C5A051F8D}"/>
+                <a16:creationId xmlns:a16="http://schemas.microsoft.com/office/drawing/2014/main" id="{8BC64413-B134-4492-B0F8-E6D70EFC8A58}"/>
               </a:ext>
             </a:extLst>
           </p:cNvPr>
@@ -22809,7 +22567,7 @@
           <p:cNvPr id="17" name="">
             <a:extLst xmlns:a="http://schemas.openxmlformats.org/drawingml/2006/main">
               <a:ext uri="{FF2B5EF4-FFF2-40B4-BE49-F238E27FC236}">
-                <a16:creationId xmlns:a16="http://schemas.microsoft.com/office/drawing/2014/main" id="{FBCFD874-4469-434E-AAFD-DFD79C2BAD1D}"/>
+                <a16:creationId xmlns:a16="http://schemas.microsoft.com/office/drawing/2014/main" id="{CEDABA6C-2BBA-416C-8510-52FB6F38286C}"/>
               </a:ext>
             </a:extLst>
           </p:cNvPr>
@@ -22840,7 +22598,7 @@
           <p:cNvPr id="18" name="">
             <a:extLst xmlns:a="http://schemas.openxmlformats.org/drawingml/2006/main">
               <a:ext uri="{FF2B5EF4-FFF2-40B4-BE49-F238E27FC236}">
-                <a16:creationId xmlns:a16="http://schemas.microsoft.com/office/drawing/2014/main" id="{4390481B-9080-4662-93AA-ECA2555C48AB}"/>
+                <a16:creationId xmlns:a16="http://schemas.microsoft.com/office/drawing/2014/main" id="{1A0BFCE5-0122-4F93-B769-5AB8C04EC058}"/>
               </a:ext>
             </a:extLst>
           </p:cNvPr>
@@ -22961,7 +22719,7 @@
           <p:cNvPr id="19" name="">
             <a:extLst xmlns:a="http://schemas.openxmlformats.org/drawingml/2006/main">
               <a:ext uri="{FF2B5EF4-FFF2-40B4-BE49-F238E27FC236}">
-                <a16:creationId xmlns:a16="http://schemas.microsoft.com/office/drawing/2014/main" id="{7988D7E8-322A-43DF-9552-E00FE26CD7EC}"/>
+                <a16:creationId xmlns:a16="http://schemas.microsoft.com/office/drawing/2014/main" id="{2F2A5B1D-A00A-424D-9F58-67D456B3C251}"/>
               </a:ext>
             </a:extLst>
           </p:cNvPr>
@@ -23082,7 +22840,7 @@
           <p:cNvPr id="20" name="">
             <a:extLst xmlns:a="http://schemas.openxmlformats.org/drawingml/2006/main">
               <a:ext uri="{FF2B5EF4-FFF2-40B4-BE49-F238E27FC236}">
-                <a16:creationId xmlns:a16="http://schemas.microsoft.com/office/drawing/2014/main" id="{ACC2204F-FA9D-43BF-8E98-CF032888286F}"/>
+                <a16:creationId xmlns:a16="http://schemas.microsoft.com/office/drawing/2014/main" id="{82924DDE-041A-4FD3-82D1-5E6C187F36E2}"/>
               </a:ext>
             </a:extLst>
           </p:cNvPr>
@@ -23203,7 +22961,7 @@
           <p:cNvPr id="21" name="">
             <a:extLst xmlns:a="http://schemas.openxmlformats.org/drawingml/2006/main">
               <a:ext uri="{FF2B5EF4-FFF2-40B4-BE49-F238E27FC236}">
-                <a16:creationId xmlns:a16="http://schemas.microsoft.com/office/drawing/2014/main" id="{E1C98CE8-0C9F-4F64-ABE2-AEA059B1A043}"/>
+                <a16:creationId xmlns:a16="http://schemas.microsoft.com/office/drawing/2014/main" id="{BB17ABAC-7067-449A-8871-5FD510ECFAF2}"/>
               </a:ext>
             </a:extLst>
           </p:cNvPr>
@@ -23234,7 +22992,7 @@
           <p:cNvPr id="22" name="">
             <a:extLst xmlns:a="http://schemas.openxmlformats.org/drawingml/2006/main">
               <a:ext uri="{FF2B5EF4-FFF2-40B4-BE49-F238E27FC236}">
-                <a16:creationId xmlns:a16="http://schemas.microsoft.com/office/drawing/2014/main" id="{BC6D90D5-1AD7-46CA-BF6F-C6B43BDB82C0}"/>
+                <a16:creationId xmlns:a16="http://schemas.microsoft.com/office/drawing/2014/main" id="{F3E84339-09F2-4538-849F-1E5BCC220E80}"/>
               </a:ext>
             </a:extLst>
           </p:cNvPr>
@@ -23355,7 +23113,7 @@
           <p:cNvPr id="23" name="">
             <a:extLst xmlns:a="http://schemas.openxmlformats.org/drawingml/2006/main">
               <a:ext uri="{FF2B5EF4-FFF2-40B4-BE49-F238E27FC236}">
-                <a16:creationId xmlns:a16="http://schemas.microsoft.com/office/drawing/2014/main" id="{5C244E50-AA7E-46E1-ABEE-C4B6D1A10E3C}"/>
+                <a16:creationId xmlns:a16="http://schemas.microsoft.com/office/drawing/2014/main" id="{100249DC-1061-4B83-86B3-A09FE7596FF3}"/>
               </a:ext>
             </a:extLst>
           </p:cNvPr>
@@ -23476,7 +23234,7 @@
           <p:cNvPr id="24" name="">
             <a:extLst xmlns:a="http://schemas.openxmlformats.org/drawingml/2006/main">
               <a:ext uri="{FF2B5EF4-FFF2-40B4-BE49-F238E27FC236}">
-                <a16:creationId xmlns:a16="http://schemas.microsoft.com/office/drawing/2014/main" id="{70FDA56B-F37C-4114-AFD7-053FF8559CAD}"/>
+                <a16:creationId xmlns:a16="http://schemas.microsoft.com/office/drawing/2014/main" id="{29B81B82-DBD0-4BEA-B99B-33B4846D168B}"/>
               </a:ext>
             </a:extLst>
           </p:cNvPr>
@@ -23597,7 +23355,7 @@
           <p:cNvPr id="25" name="">
             <a:extLst xmlns:a="http://schemas.openxmlformats.org/drawingml/2006/main">
               <a:ext uri="{FF2B5EF4-FFF2-40B4-BE49-F238E27FC236}">
-                <a16:creationId xmlns:a16="http://schemas.microsoft.com/office/drawing/2014/main" id="{50B68FEA-6800-422E-AB48-95B36704BC6E}"/>
+                <a16:creationId xmlns:a16="http://schemas.microsoft.com/office/drawing/2014/main" id="{A23694E5-2940-487F-9F95-7AF48BAC044D}"/>
               </a:ext>
             </a:extLst>
           </p:cNvPr>
@@ -23628,7 +23386,7 @@
           <p:cNvPr id="26" name="">
             <a:extLst xmlns:a="http://schemas.openxmlformats.org/drawingml/2006/main">
               <a:ext uri="{FF2B5EF4-FFF2-40B4-BE49-F238E27FC236}">
-                <a16:creationId xmlns:a16="http://schemas.microsoft.com/office/drawing/2014/main" id="{2CEC4D71-9BB1-4D5F-B004-9785C30DED91}"/>
+                <a16:creationId xmlns:a16="http://schemas.microsoft.com/office/drawing/2014/main" id="{7ECABAD5-FD32-441E-A60B-B174B77ADE0C}"/>
               </a:ext>
             </a:extLst>
           </p:cNvPr>
@@ -23749,7 +23507,7 @@
           <p:cNvPr id="27" name="">
             <a:extLst xmlns:a="http://schemas.openxmlformats.org/drawingml/2006/main">
               <a:ext uri="{FF2B5EF4-FFF2-40B4-BE49-F238E27FC236}">
-                <a16:creationId xmlns:a16="http://schemas.microsoft.com/office/drawing/2014/main" id="{E65B324A-A4BB-40BA-AA06-FAD2DB9DA7F9}"/>
+                <a16:creationId xmlns:a16="http://schemas.microsoft.com/office/drawing/2014/main" id="{5FBAE695-D2C6-4E6B-B36A-BD720548C9AE}"/>
               </a:ext>
             </a:extLst>
           </p:cNvPr>
@@ -23870,7 +23628,7 @@
           <p:cNvPr id="28" name="">
             <a:extLst xmlns:a="http://schemas.openxmlformats.org/drawingml/2006/main">
               <a:ext uri="{FF2B5EF4-FFF2-40B4-BE49-F238E27FC236}">
-                <a16:creationId xmlns:a16="http://schemas.microsoft.com/office/drawing/2014/main" id="{59426EE9-51BB-4168-90E8-245BBDF7D91B}"/>
+                <a16:creationId xmlns:a16="http://schemas.microsoft.com/office/drawing/2014/main" id="{BEBF83B2-3F59-4B2E-A4C4-A05B0FEE8776}"/>
               </a:ext>
             </a:extLst>
           </p:cNvPr>
@@ -23991,7 +23749,7 @@
           <p:cNvPr id="29" name="">
             <a:extLst xmlns:a="http://schemas.openxmlformats.org/drawingml/2006/main">
               <a:ext uri="{FF2B5EF4-FFF2-40B4-BE49-F238E27FC236}">
-                <a16:creationId xmlns:a16="http://schemas.microsoft.com/office/drawing/2014/main" id="{C48B44FC-5813-49F8-B84D-F7E51B12BAC4}"/>
+                <a16:creationId xmlns:a16="http://schemas.microsoft.com/office/drawing/2014/main" id="{A62D1EFF-77A1-4186-A57E-7D9B4A156F45}"/>
               </a:ext>
             </a:extLst>
           </p:cNvPr>
@@ -24022,7 +23780,7 @@
           <p:cNvPr id="30" name="">
             <a:extLst xmlns:a="http://schemas.openxmlformats.org/drawingml/2006/main">
               <a:ext uri="{FF2B5EF4-FFF2-40B4-BE49-F238E27FC236}">
-                <a16:creationId xmlns:a16="http://schemas.microsoft.com/office/drawing/2014/main" id="{E64E46E5-2D5A-4080-B530-928B3762FE82}"/>
+                <a16:creationId xmlns:a16="http://schemas.microsoft.com/office/drawing/2014/main" id="{349FE04D-5B4C-4FA7-AABB-F93FD1ABEFC7}"/>
               </a:ext>
             </a:extLst>
           </p:cNvPr>
@@ -24143,7 +23901,7 @@
           <p:cNvPr id="31" name="">
             <a:extLst xmlns:a="http://schemas.openxmlformats.org/drawingml/2006/main">
               <a:ext uri="{FF2B5EF4-FFF2-40B4-BE49-F238E27FC236}">
-                <a16:creationId xmlns:a16="http://schemas.microsoft.com/office/drawing/2014/main" id="{CF9EF34E-4785-4E4D-B52B-416634C9C91A}"/>
+                <a16:creationId xmlns:a16="http://schemas.microsoft.com/office/drawing/2014/main" id="{57EB6521-3385-4934-9E85-EE7FB587C906}"/>
               </a:ext>
             </a:extLst>
           </p:cNvPr>
@@ -24262,7 +24020,7 @@
     </p:spTree>
     <p:extLst>
       <p:ext uri="{BB962C8B-B14F-4D97-AF65-F5344CB8AC3E}">
-        <p14:creationId xmlns:p14="http://schemas.microsoft.com/office/powerpoint/2010/main" val="1664786586"/>
+        <p14:creationId xmlns:p14="http://schemas.microsoft.com/office/powerpoint/2010/main" val="1691754441"/>
       </p:ext>
     </p:extLst>
   </p:cSld>
@@ -24293,7 +24051,7 @@
           <p:cNvPr id="23" name="">
             <a:extLst xmlns:a="http://schemas.openxmlformats.org/drawingml/2006/main">
               <a:ext uri="{FF2B5EF4-FFF2-40B4-BE49-F238E27FC236}">
-                <a16:creationId xmlns:a16="http://schemas.microsoft.com/office/drawing/2014/main" id="{B359AE26-8AE0-43A6-BDF4-B7099720C962}"/>
+                <a16:creationId xmlns:a16="http://schemas.microsoft.com/office/drawing/2014/main" id="{F734F147-483F-4AC5-A7D8-A91E83006E02}"/>
               </a:ext>
             </a:extLst>
           </p:cNvPr>
@@ -24324,7 +24082,7 @@
           <p:cNvPr id="2" name="">
             <a:extLst xmlns:a="http://schemas.openxmlformats.org/drawingml/2006/main">
               <a:ext uri="{FF2B5EF4-FFF2-40B4-BE49-F238E27FC236}">
-                <a16:creationId xmlns:a16="http://schemas.microsoft.com/office/drawing/2014/main" id="{E7DDC9B6-6ECE-4368-8E99-D1845B8B140A}"/>
+                <a16:creationId xmlns:a16="http://schemas.microsoft.com/office/drawing/2014/main" id="{57792978-252A-49B1-88C3-7996BF9F7C29}"/>
               </a:ext>
             </a:extLst>
           </p:cNvPr>
@@ -24445,7 +24203,7 @@
           <p:cNvPr id="3" name="">
             <a:extLst xmlns:a="http://schemas.openxmlformats.org/drawingml/2006/main">
               <a:ext uri="{FF2B5EF4-FFF2-40B4-BE49-F238E27FC236}">
-                <a16:creationId xmlns:a16="http://schemas.microsoft.com/office/drawing/2014/main" id="{584EE99D-AD2F-41C2-8B1B-CC1F9BEC57E1}"/>
+                <a16:creationId xmlns:a16="http://schemas.microsoft.com/office/drawing/2014/main" id="{6CDF3DAE-C50C-45D8-A75E-EB8EB56B7AE4}"/>
               </a:ext>
             </a:extLst>
           </p:cNvPr>
@@ -24566,7 +24324,7 @@
           <p:cNvPr id="4" name="">
             <a:extLst xmlns:a="http://schemas.openxmlformats.org/drawingml/2006/main">
               <a:ext uri="{FF2B5EF4-FFF2-40B4-BE49-F238E27FC236}">
-                <a16:creationId xmlns:a16="http://schemas.microsoft.com/office/drawing/2014/main" id="{8C6E6327-4DF1-4DE6-9876-0E853F35E4E2}"/>
+                <a16:creationId xmlns:a16="http://schemas.microsoft.com/office/drawing/2014/main" id="{1395409C-D097-437F-BFEC-BFEC8163967B}"/>
               </a:ext>
             </a:extLst>
           </p:cNvPr>
@@ -24597,7 +24355,7 @@
           <p:cNvPr id="5" name="">
             <a:extLst xmlns:a="http://schemas.openxmlformats.org/drawingml/2006/main">
               <a:ext uri="{FF2B5EF4-FFF2-40B4-BE49-F238E27FC236}">
-                <a16:creationId xmlns:a16="http://schemas.microsoft.com/office/drawing/2014/main" id="{4D3D284C-B712-4409-AF79-8214091B65CE}"/>
+                <a16:creationId xmlns:a16="http://schemas.microsoft.com/office/drawing/2014/main" id="{2F441A2C-8369-4785-BE43-B464B293894F}"/>
               </a:ext>
             </a:extLst>
           </p:cNvPr>
@@ -24718,7 +24476,7 @@
           <p:cNvPr id="6" name="">
             <a:extLst xmlns:a="http://schemas.openxmlformats.org/drawingml/2006/main">
               <a:ext uri="{FF2B5EF4-FFF2-40B4-BE49-F238E27FC236}">
-                <a16:creationId xmlns:a16="http://schemas.microsoft.com/office/drawing/2014/main" id="{079F83E4-40ED-44C2-BF72-6CA09A4E64D1}"/>
+                <a16:creationId xmlns:a16="http://schemas.microsoft.com/office/drawing/2014/main" id="{B6C04563-224C-4DE4-984B-D755B76D38A3}"/>
               </a:ext>
             </a:extLst>
           </p:cNvPr>
@@ -24839,7 +24597,7 @@
           <p:cNvPr id="7" name="">
             <a:extLst xmlns:a="http://schemas.openxmlformats.org/drawingml/2006/main">
               <a:ext uri="{FF2B5EF4-FFF2-40B4-BE49-F238E27FC236}">
-                <a16:creationId xmlns:a16="http://schemas.microsoft.com/office/drawing/2014/main" id="{89769AB1-76DA-48B7-822C-0E4872BE9E6E}"/>
+                <a16:creationId xmlns:a16="http://schemas.microsoft.com/office/drawing/2014/main" id="{23527988-7460-4598-9E64-D42CF50774E8}"/>
               </a:ext>
             </a:extLst>
           </p:cNvPr>
@@ -24960,7 +24718,7 @@
           <p:cNvPr id="8" name="">
             <a:extLst xmlns:a="http://schemas.openxmlformats.org/drawingml/2006/main">
               <a:ext uri="{FF2B5EF4-FFF2-40B4-BE49-F238E27FC236}">
-                <a16:creationId xmlns:a16="http://schemas.microsoft.com/office/drawing/2014/main" id="{46217BE2-D7F4-4AC7-99DB-F3939B44BCE4}"/>
+                <a16:creationId xmlns:a16="http://schemas.microsoft.com/office/drawing/2014/main" id="{AE92B2FE-D9EE-458E-B970-3C86D0D2B869}"/>
               </a:ext>
             </a:extLst>
           </p:cNvPr>
@@ -24993,7 +24751,7 @@
           <p:cNvPr id="9" name="">
             <a:extLst xmlns:a="http://schemas.openxmlformats.org/drawingml/2006/main">
               <a:ext uri="{FF2B5EF4-FFF2-40B4-BE49-F238E27FC236}">
-                <a16:creationId xmlns:a16="http://schemas.microsoft.com/office/drawing/2014/main" id="{07D4A766-622D-440D-9D73-DC227DEEF828}"/>
+                <a16:creationId xmlns:a16="http://schemas.microsoft.com/office/drawing/2014/main" id="{87C472BB-1B16-465F-9446-7AF2F23C6256}"/>
               </a:ext>
             </a:extLst>
           </p:cNvPr>
@@ -25114,7 +24872,7 @@
           <p:cNvPr id="10" name="">
             <a:extLst xmlns:a="http://schemas.openxmlformats.org/drawingml/2006/main">
               <a:ext uri="{FF2B5EF4-FFF2-40B4-BE49-F238E27FC236}">
-                <a16:creationId xmlns:a16="http://schemas.microsoft.com/office/drawing/2014/main" id="{CB724A67-403E-43F9-8739-84D3E9AAD862}"/>
+                <a16:creationId xmlns:a16="http://schemas.microsoft.com/office/drawing/2014/main" id="{46A1A439-6938-46D1-9E28-0405E9A7310F}"/>
               </a:ext>
             </a:extLst>
           </p:cNvPr>
@@ -25235,7 +24993,7 @@
           <p:cNvPr id="11" name="">
             <a:extLst xmlns:a="http://schemas.openxmlformats.org/drawingml/2006/main">
               <a:ext uri="{FF2B5EF4-FFF2-40B4-BE49-F238E27FC236}">
-                <a16:creationId xmlns:a16="http://schemas.microsoft.com/office/drawing/2014/main" id="{FD2662AD-D3E8-4321-8DDB-3E56C3B4C6B0}"/>
+                <a16:creationId xmlns:a16="http://schemas.microsoft.com/office/drawing/2014/main" id="{EDE08806-E2AE-46A3-B17B-5F6CC877F685}"/>
               </a:ext>
             </a:extLst>
           </p:cNvPr>
@@ -25356,7 +25114,7 @@
           <p:cNvPr id="12" name="">
             <a:extLst xmlns:a="http://schemas.openxmlformats.org/drawingml/2006/main">
               <a:ext uri="{FF2B5EF4-FFF2-40B4-BE49-F238E27FC236}">
-                <a16:creationId xmlns:a16="http://schemas.microsoft.com/office/drawing/2014/main" id="{943B082F-AC36-4DC4-B692-450F102F0B64}"/>
+                <a16:creationId xmlns:a16="http://schemas.microsoft.com/office/drawing/2014/main" id="{B85770CA-8E62-42F0-AAA9-4E173CEA338B}"/>
               </a:ext>
             </a:extLst>
           </p:cNvPr>
@@ -25389,7 +25147,7 @@
           <p:cNvPr id="13" name="">
             <a:extLst xmlns:a="http://schemas.openxmlformats.org/drawingml/2006/main">
               <a:ext uri="{FF2B5EF4-FFF2-40B4-BE49-F238E27FC236}">
-                <a16:creationId xmlns:a16="http://schemas.microsoft.com/office/drawing/2014/main" id="{5C3732BB-91F4-4B41-97D7-ABA061193890}"/>
+                <a16:creationId xmlns:a16="http://schemas.microsoft.com/office/drawing/2014/main" id="{C7B6BF3A-D08C-40BD-A79F-85ACEF27C5E7}"/>
               </a:ext>
             </a:extLst>
           </p:cNvPr>
@@ -25510,7 +25268,7 @@
           <p:cNvPr id="14" name="">
             <a:extLst xmlns:a="http://schemas.openxmlformats.org/drawingml/2006/main">
               <a:ext uri="{FF2B5EF4-FFF2-40B4-BE49-F238E27FC236}">
-                <a16:creationId xmlns:a16="http://schemas.microsoft.com/office/drawing/2014/main" id="{0DF75744-6633-4E2F-8473-330139EBCE15}"/>
+                <a16:creationId xmlns:a16="http://schemas.microsoft.com/office/drawing/2014/main" id="{D34017A5-D055-4F54-B67B-27BBD39FD6B6}"/>
               </a:ext>
             </a:extLst>
           </p:cNvPr>
@@ -25631,7 +25389,7 @@
           <p:cNvPr id="15" name="">
             <a:extLst xmlns:a="http://schemas.openxmlformats.org/drawingml/2006/main">
               <a:ext uri="{FF2B5EF4-FFF2-40B4-BE49-F238E27FC236}">
-                <a16:creationId xmlns:a16="http://schemas.microsoft.com/office/drawing/2014/main" id="{F2107A53-A399-4EBC-98FD-4CDD8FF54DCA}"/>
+                <a16:creationId xmlns:a16="http://schemas.microsoft.com/office/drawing/2014/main" id="{43B25E01-5DDC-4CE5-8B4D-2BFB7798F1B6}"/>
               </a:ext>
             </a:extLst>
           </p:cNvPr>
@@ -25752,7 +25510,7 @@
           <p:cNvPr id="16" name="">
             <a:extLst xmlns:a="http://schemas.openxmlformats.org/drawingml/2006/main">
               <a:ext uri="{FF2B5EF4-FFF2-40B4-BE49-F238E27FC236}">
-                <a16:creationId xmlns:a16="http://schemas.microsoft.com/office/drawing/2014/main" id="{47C54E44-2352-4758-BCFD-4D977C1EDCED}"/>
+                <a16:creationId xmlns:a16="http://schemas.microsoft.com/office/drawing/2014/main" id="{04C32E03-AFDE-4882-98A1-EA281CFA70B2}"/>
               </a:ext>
             </a:extLst>
           </p:cNvPr>
@@ -25785,7 +25543,7 @@
           <p:cNvPr id="17" name="">
             <a:extLst xmlns:a="http://schemas.openxmlformats.org/drawingml/2006/main">
               <a:ext uri="{FF2B5EF4-FFF2-40B4-BE49-F238E27FC236}">
-                <a16:creationId xmlns:a16="http://schemas.microsoft.com/office/drawing/2014/main" id="{B57BE74B-932E-40BB-A89A-AD7E1F4F80B2}"/>
+                <a16:creationId xmlns:a16="http://schemas.microsoft.com/office/drawing/2014/main" id="{4685FB6C-66CF-4E13-9693-8F1BDB6F6089}"/>
               </a:ext>
             </a:extLst>
           </p:cNvPr>
@@ -25906,7 +25664,7 @@
           <p:cNvPr id="18" name="">
             <a:extLst xmlns:a="http://schemas.openxmlformats.org/drawingml/2006/main">
               <a:ext uri="{FF2B5EF4-FFF2-40B4-BE49-F238E27FC236}">
-                <a16:creationId xmlns:a16="http://schemas.microsoft.com/office/drawing/2014/main" id="{4890D281-2FA3-4BFA-94F7-C0D5D55E720B}"/>
+                <a16:creationId xmlns:a16="http://schemas.microsoft.com/office/drawing/2014/main" id="{E2545D5C-C88A-4137-B362-C84ECAF225C7}"/>
               </a:ext>
             </a:extLst>
           </p:cNvPr>
@@ -26027,7 +25785,7 @@
           <p:cNvPr id="19" name="">
             <a:extLst xmlns:a="http://schemas.openxmlformats.org/drawingml/2006/main">
               <a:ext uri="{FF2B5EF4-FFF2-40B4-BE49-F238E27FC236}">
-                <a16:creationId xmlns:a16="http://schemas.microsoft.com/office/drawing/2014/main" id="{30BB067E-B4D8-42C1-949C-0BFBA9908897}"/>
+                <a16:creationId xmlns:a16="http://schemas.microsoft.com/office/drawing/2014/main" id="{C144011F-9CAC-490D-BFB0-CA7EF21137C5}"/>
               </a:ext>
             </a:extLst>
           </p:cNvPr>
@@ -26148,7 +25906,7 @@
           <p:cNvPr id="20" name="">
             <a:extLst xmlns:a="http://schemas.openxmlformats.org/drawingml/2006/main">
               <a:ext uri="{FF2B5EF4-FFF2-40B4-BE49-F238E27FC236}">
-                <a16:creationId xmlns:a16="http://schemas.microsoft.com/office/drawing/2014/main" id="{616367EB-E4FB-4965-A4B2-A6290CE29C6C}"/>
+                <a16:creationId xmlns:a16="http://schemas.microsoft.com/office/drawing/2014/main" id="{24BF9428-2D01-456A-B1E4-F813B9627036}"/>
               </a:ext>
             </a:extLst>
           </p:cNvPr>
@@ -26269,7 +26027,7 @@
           <p:cNvPr id="21" name="">
             <a:extLst xmlns:a="http://schemas.openxmlformats.org/drawingml/2006/main">
               <a:ext uri="{FF2B5EF4-FFF2-40B4-BE49-F238E27FC236}">
-                <a16:creationId xmlns:a16="http://schemas.microsoft.com/office/drawing/2014/main" id="{083706D1-103C-44CC-BC1E-8C31FF64E138}"/>
+                <a16:creationId xmlns:a16="http://schemas.microsoft.com/office/drawing/2014/main" id="{D252C83B-23DD-4CAF-A163-3864F5291709}"/>
               </a:ext>
             </a:extLst>
           </p:cNvPr>
@@ -26390,7 +26148,7 @@
           <p:cNvPr id="22" name="">
             <a:extLst xmlns:a="http://schemas.openxmlformats.org/drawingml/2006/main">
               <a:ext uri="{FF2B5EF4-FFF2-40B4-BE49-F238E27FC236}">
-                <a16:creationId xmlns:a16="http://schemas.microsoft.com/office/drawing/2014/main" id="{780140EA-05B8-443A-B73E-985DE75D7235}"/>
+                <a16:creationId xmlns:a16="http://schemas.microsoft.com/office/drawing/2014/main" id="{BB9809B2-6C27-46AD-ADC4-41CBDC526D66}"/>
               </a:ext>
             </a:extLst>
           </p:cNvPr>
@@ -26509,7 +26267,7 @@
     </p:spTree>
     <p:extLst>
       <p:ext uri="{BB962C8B-B14F-4D97-AF65-F5344CB8AC3E}">
-        <p14:creationId xmlns:p14="http://schemas.microsoft.com/office/powerpoint/2010/main" val="1747384850"/>
+        <p14:creationId xmlns:p14="http://schemas.microsoft.com/office/powerpoint/2010/main" val="1484633971"/>
       </p:ext>
     </p:extLst>
   </p:cSld>

</xml_diff>